<commit_message>
Added how the models work to slides
</commit_message>
<xml_diff>
--- a/EGT309 Presentation.pptx
+++ b/EGT309 Presentation.pptx
@@ -5,10 +5,10 @@
     <p:sldMasterId id="2147484113" r:id="rId4"/>
   </p:sldMasterIdLst>
   <p:notesMasterIdLst>
-    <p:notesMasterId r:id="rId35"/>
+    <p:notesMasterId r:id="rId37"/>
   </p:notesMasterIdLst>
   <p:handoutMasterIdLst>
-    <p:handoutMasterId r:id="rId36"/>
+    <p:handoutMasterId r:id="rId38"/>
   </p:handoutMasterIdLst>
   <p:sldIdLst>
     <p:sldId id="258" r:id="rId5"/>
@@ -36,11 +36,13 @@
     <p:sldId id="280" r:id="rId27"/>
     <p:sldId id="261" r:id="rId28"/>
     <p:sldId id="263" r:id="rId29"/>
-    <p:sldId id="262" r:id="rId30"/>
+    <p:sldId id="291" r:id="rId30"/>
     <p:sldId id="281" r:id="rId31"/>
     <p:sldId id="265" r:id="rId32"/>
     <p:sldId id="260" r:id="rId33"/>
-    <p:sldId id="279" r:id="rId34"/>
+    <p:sldId id="292" r:id="rId34"/>
+    <p:sldId id="293" r:id="rId35"/>
+    <p:sldId id="279" r:id="rId36"/>
   </p:sldIdLst>
   <p:sldSz cx="12192000" cy="6858000"/>
   <p:notesSz cx="6858000" cy="9144000"/>
@@ -787,6 +789,90 @@
     <p:extLst>
       <p:ext uri="{BB962C8B-B14F-4D97-AF65-F5344CB8AC3E}">
         <p14:creationId xmlns:p14="http://schemas.microsoft.com/office/powerpoint/2010/main" val="1366932414"/>
+      </p:ext>
+    </p:extLst>
+  </p:cSld>
+  <p:clrMapOvr>
+    <a:masterClrMapping/>
+  </p:clrMapOvr>
+</p:notes>
+</file>
+
+<file path=ppt/notesSlides/notesSlide2.xml><?xml version="1.0" encoding="utf-8"?>
+<p:notes xmlns:a="http://schemas.openxmlformats.org/drawingml/2006/main" xmlns:r="http://schemas.openxmlformats.org/officeDocument/2006/relationships" xmlns:p="http://schemas.openxmlformats.org/presentationml/2006/main">
+  <p:cSld>
+    <p:spTree>
+      <p:nvGrpSpPr>
+        <p:cNvPr id="1" name=""/>
+        <p:cNvGrpSpPr/>
+        <p:nvPr/>
+      </p:nvGrpSpPr>
+      <p:grpSpPr>
+        <a:xfrm>
+          <a:off x="0" y="0"/>
+          <a:ext cx="0" cy="0"/>
+          <a:chOff x="0" y="0"/>
+          <a:chExt cx="0" cy="0"/>
+        </a:xfrm>
+      </p:grpSpPr>
+      <p:sp>
+        <p:nvSpPr>
+          <p:cNvPr id="2" name="Slide Image Placeholder 1"/>
+          <p:cNvSpPr>
+            <a:spLocks noGrp="1" noRot="1" noChangeAspect="1"/>
+          </p:cNvSpPr>
+          <p:nvPr>
+            <p:ph type="sldImg"/>
+          </p:nvPr>
+        </p:nvSpPr>
+        <p:spPr/>
+      </p:sp>
+      <p:sp>
+        <p:nvSpPr>
+          <p:cNvPr id="3" name="Notes Placeholder 2"/>
+          <p:cNvSpPr>
+            <a:spLocks noGrp="1"/>
+          </p:cNvSpPr>
+          <p:nvPr>
+            <p:ph type="body" idx="1"/>
+          </p:nvPr>
+        </p:nvSpPr>
+        <p:spPr/>
+        <p:txBody>
+          <a:bodyPr/>
+          <a:lstStyle/>
+          <a:p>
+            <a:endParaRPr lang="en-SG" dirty="0"/>
+          </a:p>
+        </p:txBody>
+      </p:sp>
+      <p:sp>
+        <p:nvSpPr>
+          <p:cNvPr id="4" name="Slide Number Placeholder 3"/>
+          <p:cNvSpPr>
+            <a:spLocks noGrp="1"/>
+          </p:cNvSpPr>
+          <p:nvPr>
+            <p:ph type="sldNum" sz="quarter" idx="5"/>
+          </p:nvPr>
+        </p:nvSpPr>
+        <p:spPr/>
+        <p:txBody>
+          <a:bodyPr/>
+          <a:lstStyle/>
+          <a:p>
+            <a:fld id="{38EFF46E-6B43-41F9-9272-B566D03A251C}" type="slidenum">
+              <a:rPr lang="en-US" smtClean="0"/>
+              <a:t>21</a:t>
+            </a:fld>
+            <a:endParaRPr lang="en-US"/>
+          </a:p>
+        </p:txBody>
+      </p:sp>
+    </p:spTree>
+    <p:extLst>
+      <p:ext uri="{BB962C8B-B14F-4D97-AF65-F5344CB8AC3E}">
+        <p14:creationId xmlns:p14="http://schemas.microsoft.com/office/powerpoint/2010/main" val="358670610"/>
       </p:ext>
     </p:extLst>
   </p:cSld>
@@ -22724,12 +22810,22 @@
             <p:ph type="title"/>
           </p:nvPr>
         </p:nvSpPr>
-        <p:spPr/>
-        <p:txBody>
-          <a:bodyPr/>
-          <a:lstStyle/>
-          <a:p>
-            <a:endParaRPr lang="en-SG"/>
+        <p:spPr>
+          <a:xfrm>
+            <a:off x="612185" y="685800"/>
+            <a:ext cx="9141415" cy="1532788"/>
+          </a:xfrm>
+        </p:spPr>
+        <p:txBody>
+          <a:bodyPr anchor="b">
+            <a:normAutofit/>
+          </a:bodyPr>
+          <a:lstStyle/>
+          <a:p>
+            <a:r>
+              <a:rPr lang="en-SG" dirty="0"/>
+              <a:t>Random forest</a:t>
+            </a:r>
           </a:p>
         </p:txBody>
       </p:sp>
@@ -22746,15 +22842,57 @@
             <a:spLocks noGrp="1"/>
           </p:cNvSpPr>
           <p:nvPr>
-            <p:ph idx="1"/>
-          </p:nvPr>
-        </p:nvSpPr>
-        <p:spPr/>
-        <p:txBody>
-          <a:bodyPr/>
-          <a:lstStyle/>
-          <a:p>
-            <a:endParaRPr lang="en-SG"/>
+            <p:ph sz="quarter" idx="13"/>
+          </p:nvPr>
+        </p:nvSpPr>
+        <p:spPr>
+          <a:xfrm>
+            <a:off x="612185" y="2958705"/>
+            <a:ext cx="9141415" cy="3213494"/>
+          </a:xfrm>
+        </p:spPr>
+        <p:txBody>
+          <a:bodyPr anchor="t">
+            <a:normAutofit/>
+          </a:bodyPr>
+          <a:lstStyle/>
+          <a:p>
+            <a:r>
+              <a:rPr lang="en-SG" sz="2400" dirty="0"/>
+              <a:t>An ensemble of decision trees tolerant of non-linear sensor interactions and resistant to noisy data (see Terms — Ensemble, </a:t>
+            </a:r>
+            <a:r>
+              <a:rPr lang="en-SG" sz="2400" dirty="0" err="1"/>
+              <a:t>n_estimators</a:t>
+            </a:r>
+            <a:r>
+              <a:rPr lang="en-SG" sz="2400" dirty="0"/>
+              <a:t>). Uses </a:t>
+            </a:r>
+            <a:r>
+              <a:rPr lang="en-SG" sz="2400" dirty="0" err="1"/>
+              <a:t>class_weight</a:t>
+            </a:r>
+            <a:r>
+              <a:rPr lang="en-SG" sz="2400" dirty="0"/>
+              <a:t>="balanced" (see Terms — </a:t>
+            </a:r>
+            <a:r>
+              <a:rPr lang="en-SG" sz="2400" dirty="0" err="1"/>
+              <a:t>class_weight</a:t>
+            </a:r>
+            <a:r>
+              <a:rPr lang="en-SG" sz="2400" dirty="0"/>
+              <a:t>) for class imbalance. Sweeps </a:t>
+            </a:r>
+            <a:r>
+              <a:rPr lang="en-SG" sz="2400" dirty="0" err="1"/>
+              <a:t>n_estimators</a:t>
+            </a:r>
+            <a:r>
+              <a:rPr lang="en-SG" sz="2400" dirty="0"/>
+              <a:t> 10 to 300, selecting the best value via macro F1-score.</a:t>
+            </a:r>
           </a:p>
         </p:txBody>
       </p:sp>
@@ -22804,12 +22942,27 @@
             <p:ph type="title"/>
           </p:nvPr>
         </p:nvSpPr>
-        <p:spPr/>
-        <p:txBody>
-          <a:bodyPr/>
-          <a:lstStyle/>
-          <a:p>
-            <a:endParaRPr lang="en-SG"/>
+        <p:spPr>
+          <a:xfrm>
+            <a:off x="612185" y="685800"/>
+            <a:ext cx="9141415" cy="1532788"/>
+          </a:xfrm>
+        </p:spPr>
+        <p:txBody>
+          <a:bodyPr anchor="b">
+            <a:normAutofit/>
+          </a:bodyPr>
+          <a:lstStyle/>
+          <a:p>
+            <a:r>
+              <a:rPr lang="en-SG" sz="6100"/>
+              <a:t>K-nearest </a:t>
+            </a:r>
+            <a:r>
+              <a:rPr lang="en-SG" sz="6100" err="1"/>
+              <a:t>neighbors</a:t>
+            </a:r>
+            <a:endParaRPr lang="en-SG" sz="6100"/>
           </a:p>
         </p:txBody>
       </p:sp>
@@ -22826,15 +22979,65 @@
             <a:spLocks noGrp="1"/>
           </p:cNvSpPr>
           <p:nvPr>
-            <p:ph idx="1"/>
-          </p:nvPr>
-        </p:nvSpPr>
-        <p:spPr/>
-        <p:txBody>
-          <a:bodyPr/>
-          <a:lstStyle/>
-          <a:p>
-            <a:endParaRPr lang="en-SG"/>
+            <p:ph sz="quarter" idx="13"/>
+          </p:nvPr>
+        </p:nvSpPr>
+        <p:spPr>
+          <a:xfrm>
+            <a:off x="612185" y="2958705"/>
+            <a:ext cx="9141415" cy="3213494"/>
+          </a:xfrm>
+        </p:spPr>
+        <p:txBody>
+          <a:bodyPr anchor="t">
+            <a:noAutofit/>
+          </a:bodyPr>
+          <a:lstStyle/>
+          <a:p>
+            <a:r>
+              <a:rPr lang="en-SG" sz="2400" dirty="0"/>
+              <a:t>A distance-based classifier that captures non-linear thresholds and sensor clusters (see Terms — </a:t>
+            </a:r>
+            <a:r>
+              <a:rPr lang="en-SG" sz="2400" dirty="0" err="1"/>
+              <a:t>GridSearchCV</a:t>
+            </a:r>
+            <a:r>
+              <a:rPr lang="en-SG" sz="2400" dirty="0"/>
+              <a:t>). </a:t>
+            </a:r>
+            <a:r>
+              <a:rPr lang="en-SG" sz="2400" dirty="0" err="1"/>
+              <a:t>StandardScaler</a:t>
+            </a:r>
+            <a:r>
+              <a:rPr lang="en-SG" sz="2400" dirty="0"/>
+              <a:t> prevents large-scale sensors from dominating distance (see Terms — </a:t>
+            </a:r>
+            <a:r>
+              <a:rPr lang="en-SG" sz="2400" dirty="0" err="1"/>
+              <a:t>StandardScaler</a:t>
+            </a:r>
+            <a:r>
+              <a:rPr lang="en-SG" sz="2400" dirty="0"/>
+              <a:t>). Tunes </a:t>
+            </a:r>
+            <a:r>
+              <a:rPr lang="en-SG" sz="2400" dirty="0" err="1"/>
+              <a:t>neighbor</a:t>
+            </a:r>
+            <a:r>
+              <a:rPr lang="en-SG" sz="2400" dirty="0"/>
+              <a:t> counts, distance metrics, and weight configurations via </a:t>
+            </a:r>
+            <a:r>
+              <a:rPr lang="en-SG" sz="2400" dirty="0" err="1"/>
+              <a:t>GridSearchCV</a:t>
+            </a:r>
+            <a:r>
+              <a:rPr lang="en-SG" sz="2400" dirty="0"/>
+              <a:t> with 5-fold CV and macro F1 scoring.</a:t>
+            </a:r>
           </a:p>
         </p:txBody>
       </p:sp>
@@ -22884,12 +23087,22 @@
             <p:ph type="title"/>
           </p:nvPr>
         </p:nvSpPr>
-        <p:spPr/>
-        <p:txBody>
-          <a:bodyPr/>
-          <a:lstStyle/>
-          <a:p>
-            <a:endParaRPr lang="en-SG"/>
+        <p:spPr>
+          <a:xfrm>
+            <a:off x="612185" y="685800"/>
+            <a:ext cx="9141415" cy="1532788"/>
+          </a:xfrm>
+        </p:spPr>
+        <p:txBody>
+          <a:bodyPr anchor="b">
+            <a:normAutofit/>
+          </a:bodyPr>
+          <a:lstStyle/>
+          <a:p>
+            <a:r>
+              <a:rPr lang="en-SG" sz="6700"/>
+              <a:t>Logistic regression</a:t>
+            </a:r>
           </a:p>
         </p:txBody>
       </p:sp>
@@ -22906,15 +23119,57 @@
             <a:spLocks noGrp="1"/>
           </p:cNvSpPr>
           <p:nvPr>
-            <p:ph idx="1"/>
-          </p:nvPr>
-        </p:nvSpPr>
-        <p:spPr/>
-        <p:txBody>
-          <a:bodyPr/>
-          <a:lstStyle/>
-          <a:p>
-            <a:endParaRPr lang="en-SG"/>
+            <p:ph sz="quarter" idx="13"/>
+          </p:nvPr>
+        </p:nvSpPr>
+        <p:spPr>
+          <a:xfrm>
+            <a:off x="612185" y="2958704"/>
+            <a:ext cx="10236343" cy="3710655"/>
+          </a:xfrm>
+        </p:spPr>
+        <p:txBody>
+          <a:bodyPr anchor="t">
+            <a:normAutofit/>
+          </a:bodyPr>
+          <a:lstStyle/>
+          <a:p>
+            <a:r>
+              <a:rPr lang="en-SG" sz="2000" dirty="0"/>
+              <a:t>A linear classifier valued for interpretability — coefficients trace which sensors drive predictions (see Terms — Multinomial, L2 regularization, Regularization strength (C), L-BFGS). </a:t>
+            </a:r>
+            <a:r>
+              <a:rPr lang="en-SG" sz="2000" dirty="0" err="1"/>
+              <a:t>StandardScaler</a:t>
+            </a:r>
+            <a:r>
+              <a:rPr lang="en-SG" sz="2000" dirty="0"/>
+              <a:t> ensures fair L2 penalisation (see Terms — </a:t>
+            </a:r>
+            <a:r>
+              <a:rPr lang="en-SG" sz="2000" dirty="0" err="1"/>
+              <a:t>StandardScaler</a:t>
+            </a:r>
+            <a:r>
+              <a:rPr lang="en-SG" sz="2000" dirty="0"/>
+              <a:t>). Uses </a:t>
+            </a:r>
+            <a:r>
+              <a:rPr lang="en-SG" sz="2000" dirty="0" err="1"/>
+              <a:t>class_weight</a:t>
+            </a:r>
+            <a:r>
+              <a:rPr lang="en-SG" sz="2000" dirty="0"/>
+              <a:t>="balanced" (see Terms — </a:t>
+            </a:r>
+            <a:r>
+              <a:rPr lang="en-SG" sz="2000" dirty="0" err="1"/>
+              <a:t>class_weight</a:t>
+            </a:r>
+            <a:r>
+              <a:rPr lang="en-SG" sz="2000" dirty="0"/>
+              <a:t>). Sweeps C 0.001 to 100 via macro F1-score, suppressing noisy features (Temperature, Humidity) while preserving sensor signal.</a:t>
+            </a:r>
           </a:p>
         </p:txBody>
       </p:sp>
@@ -23192,14 +23447,14 @@
           <a:lstStyle/>
           <a:p>
             <a:r>
-              <a:rPr lang="en-US" b="1" dirty="0" err="1"/>
+              <a:rPr lang="en-US" sz="2800" b="1" dirty="0" err="1"/>
               <a:t>GridSearchCV</a:t>
             </a:r>
             <a:r>
-              <a:rPr lang="en-US" dirty="0"/>
+              <a:rPr lang="en-US" sz="2800" dirty="0"/>
               <a:t> — An automated search that tries every combination of hyperparameters (e.g., different neighbor counts and distance metrics for KNN) using cross-validation, then picks the combination with the best score.</a:t>
             </a:r>
-            <a:endParaRPr lang="en-SG" dirty="0"/>
+            <a:endParaRPr lang="en-SG" sz="2800" dirty="0"/>
           </a:p>
         </p:txBody>
       </p:sp>
@@ -23238,7 +23493,7 @@
           <p:cNvPr id="2" name="Title 1">
             <a:extLst>
               <a:ext uri="{FF2B5EF4-FFF2-40B4-BE49-F238E27FC236}">
-                <a16:creationId xmlns:a16="http://schemas.microsoft.com/office/drawing/2014/main" id="{67F09645-A35C-9C66-D06C-2C2757020AAE}"/>
+                <a16:creationId xmlns:a16="http://schemas.microsoft.com/office/drawing/2014/main" id="{7BCA37B9-217F-D459-3DB9-22FA97E4AA44}"/>
               </a:ext>
             </a:extLst>
           </p:cNvPr>
@@ -23251,8 +23506,8 @@
         </p:nvSpPr>
         <p:spPr>
           <a:xfrm>
-            <a:off x="612648" y="685800"/>
-            <a:ext cx="10972800" cy="1828800"/>
+            <a:off x="612185" y="685800"/>
+            <a:ext cx="9141415" cy="1532788"/>
           </a:xfrm>
         </p:spPr>
         <p:txBody>
@@ -23262,10 +23517,9 @@
           <a:lstStyle/>
           <a:p>
             <a:r>
-              <a:rPr lang="en-SG" sz="7000" b="1" dirty="0"/>
-              <a:t>Logistic Regression</a:t>
-            </a:r>
-            <a:endParaRPr lang="en-SG" sz="7000" dirty="0"/>
+              <a:rPr lang="en-SG" sz="6700" dirty="0"/>
+              <a:t>Logistic regression</a:t>
+            </a:r>
           </a:p>
         </p:txBody>
       </p:sp>
@@ -23274,7 +23528,7 @@
           <p:cNvPr id="3" name="Content Placeholder 2">
             <a:extLst>
               <a:ext uri="{FF2B5EF4-FFF2-40B4-BE49-F238E27FC236}">
-                <a16:creationId xmlns:a16="http://schemas.microsoft.com/office/drawing/2014/main" id="{49697566-F9B1-0A03-784D-3E002FE11AFB}"/>
+                <a16:creationId xmlns:a16="http://schemas.microsoft.com/office/drawing/2014/main" id="{2D2535EC-99CD-3889-1D65-499FAD240725}"/>
               </a:ext>
             </a:extLst>
           </p:cNvPr>
@@ -23287,137 +23541,145 @@
         </p:nvSpPr>
         <p:spPr>
           <a:xfrm>
-            <a:off x="612775" y="3429000"/>
-            <a:ext cx="10972800" cy="2743198"/>
-          </a:xfrm>
-        </p:spPr>
-        <p:txBody>
-          <a:bodyPr>
-            <a:normAutofit/>
+            <a:off x="612185" y="2708920"/>
+            <a:ext cx="10524375" cy="3960439"/>
+          </a:xfrm>
+        </p:spPr>
+        <p:txBody>
+          <a:bodyPr anchor="t">
+            <a:noAutofit/>
           </a:bodyPr>
           <a:lstStyle/>
           <a:p>
             <a:pPr>
               <a:lnSpc>
-                <a:spcPct val="90000"/>
+                <a:spcPct val="140000"/>
               </a:lnSpc>
             </a:pPr>
             <a:r>
-              <a:rPr lang="en-US" b="1" dirty="0"/>
+              <a:rPr lang="en-US" sz="1400" b="1" dirty="0"/>
               <a:t>Multinomial</a:t>
             </a:r>
             <a:r>
-              <a:rPr lang="en-US" dirty="0"/>
+              <a:rPr lang="en-US" sz="1400" dirty="0"/>
               <a:t> — A classification strategy that treats all classes simultaneously using a </a:t>
             </a:r>
             <a:r>
-              <a:rPr lang="en-US" dirty="0" err="1"/>
+              <a:rPr lang="en-US" sz="1400" dirty="0" err="1"/>
               <a:t>softmax</a:t>
             </a:r>
             <a:r>
-              <a:rPr lang="en-US" dirty="0"/>
+              <a:rPr lang="en-US" sz="1400" dirty="0"/>
               <a:t> function, producing a probability for each class that sums to 1.</a:t>
             </a:r>
           </a:p>
           <a:p>
             <a:pPr>
               <a:lnSpc>
-                <a:spcPct val="90000"/>
+                <a:spcPct val="140000"/>
               </a:lnSpc>
             </a:pPr>
             <a:r>
-              <a:rPr lang="en-US" b="1" dirty="0"/>
+              <a:rPr lang="en-US" sz="1400" b="1" dirty="0"/>
               <a:t>L2 regularization</a:t>
             </a:r>
             <a:r>
-              <a:rPr lang="en-US" dirty="0"/>
+              <a:rPr lang="en-US" sz="1400" dirty="0"/>
               <a:t> — The default penalty in logistic regression. It adds the sum of squared coefficients to the loss function, </a:t>
             </a:r>
             <a:r>
-              <a:rPr lang="en-US" dirty="0" err="1"/>
+              <a:rPr lang="en-US" sz="1400" dirty="0" err="1"/>
               <a:t>penalising</a:t>
             </a:r>
             <a:r>
-              <a:rPr lang="en-US" dirty="0"/>
+              <a:rPr lang="en-US" sz="1400" dirty="0"/>
               <a:t> large coefficients and preventing overfitting. In scikit-learn 1.8, L2 is auto-selected when using the </a:t>
             </a:r>
             <a:r>
-              <a:rPr lang="en-US" dirty="0" err="1"/>
+              <a:rPr lang="en-US" sz="1400" dirty="0" err="1"/>
               <a:t>lbfgs</a:t>
             </a:r>
             <a:r>
-              <a:rPr lang="en-US" dirty="0"/>
+              <a:rPr lang="en-US" sz="1400" dirty="0"/>
               <a:t> solver — even though penalty='l2' is no longer written explicitly in code.</a:t>
             </a:r>
           </a:p>
           <a:p>
             <a:pPr>
               <a:lnSpc>
-                <a:spcPct val="90000"/>
+                <a:spcPct val="140000"/>
               </a:lnSpc>
             </a:pPr>
             <a:r>
-              <a:rPr lang="en-US" b="1" dirty="0"/>
+              <a:rPr lang="en-US" sz="1400" b="1" dirty="0"/>
               <a:t>Regularization strength (C)</a:t>
             </a:r>
             <a:r>
-              <a:rPr lang="en-US" dirty="0"/>
+              <a:rPr lang="en-US" sz="1400" dirty="0"/>
               <a:t> — Controls how much the model is allowed to grow its coefficients by controlling the L2 penalty. Small C means strong regularization (simpler model, less overfitting); large C means weak regularization (more complex, can overfit). This is the primary tuning knob for LR.</a:t>
             </a:r>
           </a:p>
           <a:p>
             <a:pPr>
               <a:lnSpc>
-                <a:spcPct val="90000"/>
+                <a:spcPct val="140000"/>
               </a:lnSpc>
             </a:pPr>
             <a:r>
-              <a:rPr lang="en-US" b="1" dirty="0"/>
+              <a:rPr lang="en-US" sz="1400" b="1" dirty="0"/>
               <a:t>L-BFGS</a:t>
             </a:r>
             <a:r>
-              <a:rPr lang="en-US" dirty="0"/>
+              <a:rPr lang="en-US" sz="1400" dirty="0"/>
               <a:t> — The default </a:t>
             </a:r>
             <a:r>
-              <a:rPr lang="en-US" dirty="0" err="1"/>
+              <a:rPr lang="en-US" sz="1400" dirty="0" err="1"/>
               <a:t>optimisation</a:t>
             </a:r>
             <a:r>
-              <a:rPr lang="en-US" dirty="0"/>
+              <a:rPr lang="en-US" sz="1400" dirty="0"/>
               <a:t> algorithm used by Logistic Regression. It iteratively adjusts coefficients to </a:t>
             </a:r>
             <a:r>
-              <a:rPr lang="en-US" dirty="0" err="1"/>
+              <a:rPr lang="en-US" sz="1400" dirty="0" err="1"/>
               <a:t>minimise</a:t>
             </a:r>
             <a:r>
-              <a:rPr lang="en-US" dirty="0"/>
+              <a:rPr lang="en-US" sz="1400" dirty="0"/>
               <a:t> the loss function (error + L2 penalty). Unlike tree-based models (RF) or distance-based models (KNN), LR needs an </a:t>
             </a:r>
             <a:r>
-              <a:rPr lang="en-US" dirty="0" err="1"/>
+              <a:rPr lang="en-US" sz="1400" dirty="0" err="1"/>
               <a:t>optimiser</a:t>
             </a:r>
             <a:r>
-              <a:rPr lang="en-US" dirty="0"/>
+              <a:rPr lang="en-US" sz="1400" dirty="0"/>
               <a:t> to find its coefficients.</a:t>
             </a:r>
           </a:p>
           <a:p>
             <a:pPr>
               <a:lnSpc>
-                <a:spcPct val="90000"/>
+                <a:spcPct val="140000"/>
               </a:lnSpc>
             </a:pPr>
-            <a:endParaRPr lang="en-SG" dirty="0"/>
+            <a:endParaRPr lang="en-SG" sz="1400" dirty="0"/>
+          </a:p>
+          <a:p>
+            <a:pPr>
+              <a:lnSpc>
+                <a:spcPct val="140000"/>
+              </a:lnSpc>
+            </a:pPr>
+            <a:endParaRPr lang="en-SG" sz="1400" dirty="0"/>
           </a:p>
         </p:txBody>
       </p:sp>
     </p:spTree>
     <p:extLst>
       <p:ext uri="{BB962C8B-B14F-4D97-AF65-F5344CB8AC3E}">
-        <p14:creationId xmlns:p14="http://schemas.microsoft.com/office/powerpoint/2010/main" val="2783837269"/>
+        <p14:creationId xmlns:p14="http://schemas.microsoft.com/office/powerpoint/2010/main" val="1114470984"/>
       </p:ext>
     </p:extLst>
   </p:cSld>
@@ -23910,6 +24172,147 @@
 </file>
 
 <file path=ppt/slides/slide30.xml><?xml version="1.0" encoding="utf-8"?>
+<p:sld xmlns:a="http://schemas.openxmlformats.org/drawingml/2006/main" xmlns:r="http://schemas.openxmlformats.org/officeDocument/2006/relationships" xmlns:p="http://schemas.openxmlformats.org/presentationml/2006/main">
+  <p:cSld>
+    <p:spTree>
+      <p:nvGrpSpPr>
+        <p:cNvPr id="1" name=""/>
+        <p:cNvGrpSpPr/>
+        <p:nvPr/>
+      </p:nvGrpSpPr>
+      <p:grpSpPr>
+        <a:xfrm>
+          <a:off x="0" y="0"/>
+          <a:ext cx="0" cy="0"/>
+          <a:chOff x="0" y="0"/>
+          <a:chExt cx="0" cy="0"/>
+        </a:xfrm>
+      </p:grpSpPr>
+      <p:sp>
+        <p:nvSpPr>
+          <p:cNvPr id="2" name="Title 1">
+            <a:extLst>
+              <a:ext uri="{FF2B5EF4-FFF2-40B4-BE49-F238E27FC236}">
+                <a16:creationId xmlns:a16="http://schemas.microsoft.com/office/drawing/2014/main" id="{917A164B-6142-D78E-30B2-4D4E577450D2}"/>
+              </a:ext>
+            </a:extLst>
+          </p:cNvPr>
+          <p:cNvSpPr>
+            <a:spLocks noGrp="1"/>
+          </p:cNvSpPr>
+          <p:nvPr>
+            <p:ph type="ctrTitle"/>
+          </p:nvPr>
+        </p:nvSpPr>
+        <p:spPr/>
+        <p:txBody>
+          <a:bodyPr/>
+          <a:lstStyle/>
+          <a:p>
+            <a:r>
+              <a:rPr lang="en-SG" dirty="0"/>
+              <a:t>COMPARISON</a:t>
+            </a:r>
+          </a:p>
+        </p:txBody>
+      </p:sp>
+    </p:spTree>
+    <p:extLst>
+      <p:ext uri="{BB962C8B-B14F-4D97-AF65-F5344CB8AC3E}">
+        <p14:creationId xmlns:p14="http://schemas.microsoft.com/office/powerpoint/2010/main" val="1168183960"/>
+      </p:ext>
+    </p:extLst>
+  </p:cSld>
+  <p:clrMapOvr>
+    <a:masterClrMapping/>
+  </p:clrMapOvr>
+</p:sld>
+</file>
+
+<file path=ppt/slides/slide31.xml><?xml version="1.0" encoding="utf-8"?>
+<p:sld xmlns:a="http://schemas.openxmlformats.org/drawingml/2006/main" xmlns:r="http://schemas.openxmlformats.org/officeDocument/2006/relationships" xmlns:p="http://schemas.openxmlformats.org/presentationml/2006/main">
+  <p:cSld>
+    <p:spTree>
+      <p:nvGrpSpPr>
+        <p:cNvPr id="1" name=""/>
+        <p:cNvGrpSpPr/>
+        <p:nvPr/>
+      </p:nvGrpSpPr>
+      <p:grpSpPr>
+        <a:xfrm>
+          <a:off x="0" y="0"/>
+          <a:ext cx="0" cy="0"/>
+          <a:chOff x="0" y="0"/>
+          <a:chExt cx="0" cy="0"/>
+        </a:xfrm>
+      </p:grpSpPr>
+      <p:sp>
+        <p:nvSpPr>
+          <p:cNvPr id="2" name="Title 1">
+            <a:extLst>
+              <a:ext uri="{FF2B5EF4-FFF2-40B4-BE49-F238E27FC236}">
+                <a16:creationId xmlns:a16="http://schemas.microsoft.com/office/drawing/2014/main" id="{9CFC4A9C-B598-F116-4E8D-407083A2ED77}"/>
+              </a:ext>
+            </a:extLst>
+          </p:cNvPr>
+          <p:cNvSpPr>
+            <a:spLocks noGrp="1"/>
+          </p:cNvSpPr>
+          <p:nvPr>
+            <p:ph type="title"/>
+          </p:nvPr>
+        </p:nvSpPr>
+        <p:spPr/>
+        <p:txBody>
+          <a:bodyPr/>
+          <a:lstStyle/>
+          <a:p>
+            <a:r>
+              <a:rPr lang="en-SG" dirty="0"/>
+              <a:t>BEST MODEL</a:t>
+            </a:r>
+          </a:p>
+        </p:txBody>
+      </p:sp>
+      <p:sp>
+        <p:nvSpPr>
+          <p:cNvPr id="3" name="Content Placeholder 2">
+            <a:extLst>
+              <a:ext uri="{FF2B5EF4-FFF2-40B4-BE49-F238E27FC236}">
+                <a16:creationId xmlns:a16="http://schemas.microsoft.com/office/drawing/2014/main" id="{C474EAD9-445F-4A61-D3D4-354D23F4D65A}"/>
+              </a:ext>
+            </a:extLst>
+          </p:cNvPr>
+          <p:cNvSpPr>
+            <a:spLocks noGrp="1"/>
+          </p:cNvSpPr>
+          <p:nvPr>
+            <p:ph idx="1"/>
+          </p:nvPr>
+        </p:nvSpPr>
+        <p:spPr/>
+        <p:txBody>
+          <a:bodyPr/>
+          <a:lstStyle/>
+          <a:p>
+            <a:endParaRPr lang="en-SG"/>
+          </a:p>
+        </p:txBody>
+      </p:sp>
+    </p:spTree>
+    <p:extLst>
+      <p:ext uri="{BB962C8B-B14F-4D97-AF65-F5344CB8AC3E}">
+        <p14:creationId xmlns:p14="http://schemas.microsoft.com/office/powerpoint/2010/main" val="2773766595"/>
+      </p:ext>
+    </p:extLst>
+  </p:cSld>
+  <p:clrMapOvr>
+    <a:masterClrMapping/>
+  </p:clrMapOvr>
+</p:sld>
+</file>
+
+<file path=ppt/slides/slide32.xml><?xml version="1.0" encoding="utf-8"?>
 <p:sld xmlns:a="http://schemas.openxmlformats.org/drawingml/2006/main" xmlns:r="http://schemas.openxmlformats.org/officeDocument/2006/relationships" xmlns:p="http://schemas.openxmlformats.org/presentationml/2006/main">
   <p:cSld>
     <p:spTree>
@@ -25496,6 +25899,26 @@
 </file>
 
 <file path=customXml/item1.xml><?xml version="1.0" encoding="utf-8"?>
+<p:properties xmlns:p="http://schemas.microsoft.com/office/2006/metadata/properties" xmlns:xsi="http://www.w3.org/2001/XMLSchema-instance" xmlns:pc="http://schemas.microsoft.com/office/infopath/2007/PartnerControls">
+  <documentManagement>
+    <_ip_UnifiedCompliancePolicyUIAction xmlns="http://schemas.microsoft.com/sharepoint/v3" xsi:nil="true"/>
+    <Image xmlns="71af3243-3dd4-4a8d-8c0d-dd76da1f02a5">
+      <Url xsi:nil="true"/>
+      <Description xsi:nil="true"/>
+    </Image>
+    <Status xmlns="71af3243-3dd4-4a8d-8c0d-dd76da1f02a5">Not started</Status>
+    <Background xmlns="71af3243-3dd4-4a8d-8c0d-dd76da1f02a5">false</Background>
+    <_ip_UnifiedCompliancePolicyProperties xmlns="http://schemas.microsoft.com/sharepoint/v3" xsi:nil="true"/>
+    <ImageTagsTaxHTField xmlns="71af3243-3dd4-4a8d-8c0d-dd76da1f02a5">
+      <Terms xmlns="http://schemas.microsoft.com/office/infopath/2007/PartnerControls"/>
+    </ImageTagsTaxHTField>
+    <TaxCatchAll xmlns="230e9df3-be65-4c73-a93b-d1236ebd677e" xsi:nil="true"/>
+    <MediaServiceKeyPoints xmlns="71af3243-3dd4-4a8d-8c0d-dd76da1f02a5" xsi:nil="true"/>
+  </documentManagement>
+</p:properties>
+</file>
+
+<file path=customXml/item2.xml><?xml version="1.0" encoding="utf-8"?>
 <ct:contentTypeSchema xmlns:ct="http://schemas.microsoft.com/office/2006/metadata/contentType" xmlns:ma="http://schemas.microsoft.com/office/2006/metadata/properties/metaAttributes" ct:_="" ma:_="" ma:contentTypeName="Document" ma:contentTypeID="0x01010079F111ED35F8CC479449609E8A0923A6" ma:contentTypeVersion="32" ma:contentTypeDescription="Create a new document." ma:contentTypeScope="" ma:versionID="0635a23c60cc3de58ab4c1efc88efc6e">
   <xsd:schema xmlns:xsd="http://www.w3.org/2001/XMLSchema" xmlns:xs="http://www.w3.org/2001/XMLSchema" xmlns:p="http://schemas.microsoft.com/office/2006/metadata/properties" xmlns:ns1="http://schemas.microsoft.com/sharepoint/v3" xmlns:ns2="71af3243-3dd4-4a8d-8c0d-dd76da1f02a5" xmlns:ns3="16c05727-aa75-4e4a-9b5f-8a80a1165891" xmlns:ns4="230e9df3-be65-4c73-a93b-d1236ebd677e" targetNamespace="http://schemas.microsoft.com/office/2006/metadata/properties" ma:root="true" ma:fieldsID="b2ec4e1d644ed04c8d3fd0ef60d056a4" ns1:_="" ns2:_="" ns3:_="" ns4:_="">
     <xsd:import namespace="http://schemas.microsoft.com/sharepoint/v3"/>
@@ -25825,26 +26248,6 @@
 </ct:contentTypeSchema>
 </file>
 
-<file path=customXml/item2.xml><?xml version="1.0" encoding="utf-8"?>
-<p:properties xmlns:p="http://schemas.microsoft.com/office/2006/metadata/properties" xmlns:xsi="http://www.w3.org/2001/XMLSchema-instance" xmlns:pc="http://schemas.microsoft.com/office/infopath/2007/PartnerControls">
-  <documentManagement>
-    <_ip_UnifiedCompliancePolicyUIAction xmlns="http://schemas.microsoft.com/sharepoint/v3" xsi:nil="true"/>
-    <Image xmlns="71af3243-3dd4-4a8d-8c0d-dd76da1f02a5">
-      <Url xsi:nil="true"/>
-      <Description xsi:nil="true"/>
-    </Image>
-    <Status xmlns="71af3243-3dd4-4a8d-8c0d-dd76da1f02a5">Not started</Status>
-    <Background xmlns="71af3243-3dd4-4a8d-8c0d-dd76da1f02a5">false</Background>
-    <_ip_UnifiedCompliancePolicyProperties xmlns="http://schemas.microsoft.com/sharepoint/v3" xsi:nil="true"/>
-    <ImageTagsTaxHTField xmlns="71af3243-3dd4-4a8d-8c0d-dd76da1f02a5">
-      <Terms xmlns="http://schemas.microsoft.com/office/infopath/2007/PartnerControls"/>
-    </ImageTagsTaxHTField>
-    <TaxCatchAll xmlns="230e9df3-be65-4c73-a93b-d1236ebd677e" xsi:nil="true"/>
-    <MediaServiceKeyPoints xmlns="71af3243-3dd4-4a8d-8c0d-dd76da1f02a5" xsi:nil="true"/>
-  </documentManagement>
-</p:properties>
-</file>
-
 <file path=customXml/item3.xml><?xml version="1.0" encoding="utf-8"?>
 <?mso-contentType ?>
 <FormTemplates xmlns="http://schemas.microsoft.com/sharepoint/v3/contenttype/forms">
@@ -25855,6 +26258,18 @@
 </file>
 
 <file path=customXml/itemProps1.xml><?xml version="1.0" encoding="utf-8"?>
+<ds:datastoreItem xmlns:ds="http://schemas.openxmlformats.org/officeDocument/2006/customXml" ds:itemID="{EEA42C18-4C38-43BB-8CE3-C963EDA9CBBA}">
+  <ds:schemaRefs>
+    <ds:schemaRef ds:uri="http://schemas.microsoft.com/office/2006/metadata/properties"/>
+    <ds:schemaRef ds:uri="http://schemas.microsoft.com/office/infopath/2007/PartnerControls"/>
+    <ds:schemaRef ds:uri="http://schemas.microsoft.com/sharepoint/v3"/>
+    <ds:schemaRef ds:uri="71af3243-3dd4-4a8d-8c0d-dd76da1f02a5"/>
+    <ds:schemaRef ds:uri="230e9df3-be65-4c73-a93b-d1236ebd677e"/>
+  </ds:schemaRefs>
+</ds:datastoreItem>
+</file>
+
+<file path=customXml/itemProps2.xml><?xml version="1.0" encoding="utf-8"?>
 <ds:datastoreItem xmlns:ds="http://schemas.openxmlformats.org/officeDocument/2006/customXml" ds:itemID="{CC3B381C-6232-408C-B65A-8475398E4C36}">
   <ds:schemaRefs>
     <ds:schemaRef ds:uri="http://schemas.microsoft.com/office/2006/metadata/contentType"/>
@@ -25875,18 +26290,6 @@
 </ds:datastoreItem>
 </file>
 
-<file path=customXml/itemProps2.xml><?xml version="1.0" encoding="utf-8"?>
-<ds:datastoreItem xmlns:ds="http://schemas.openxmlformats.org/officeDocument/2006/customXml" ds:itemID="{EEA42C18-4C38-43BB-8CE3-C963EDA9CBBA}">
-  <ds:schemaRefs>
-    <ds:schemaRef ds:uri="http://schemas.microsoft.com/office/2006/metadata/properties"/>
-    <ds:schemaRef ds:uri="http://schemas.microsoft.com/office/infopath/2007/PartnerControls"/>
-    <ds:schemaRef ds:uri="http://schemas.microsoft.com/sharepoint/v3"/>
-    <ds:schemaRef ds:uri="71af3243-3dd4-4a8d-8c0d-dd76da1f02a5"/>
-    <ds:schemaRef ds:uri="230e9df3-be65-4c73-a93b-d1236ebd677e"/>
-  </ds:schemaRefs>
-</ds:datastoreItem>
-</file>
-
 <file path=customXml/itemProps3.xml><?xml version="1.0" encoding="utf-8"?>
 <ds:datastoreItem xmlns:ds="http://schemas.openxmlformats.org/officeDocument/2006/customXml" ds:itemID="{0DE0AE46-2EED-447A-8B24-DFD65B70D448}">
   <ds:schemaRefs>

</xml_diff>

<commit_message>
brief explanation on clean.py under how models work
</commit_message>
<xml_diff>
--- a/EGT309 Presentation.pptx
+++ b/EGT309 Presentation.pptx
@@ -5,10 +5,10 @@
     <p:sldMasterId id="2147484113" r:id="rId4"/>
   </p:sldMasterIdLst>
   <p:notesMasterIdLst>
-    <p:notesMasterId r:id="rId37"/>
+    <p:notesMasterId r:id="rId38"/>
   </p:notesMasterIdLst>
   <p:handoutMasterIdLst>
-    <p:handoutMasterId r:id="rId38"/>
+    <p:handoutMasterId r:id="rId39"/>
   </p:handoutMasterIdLst>
   <p:sldIdLst>
     <p:sldId id="258" r:id="rId5"/>
@@ -33,16 +33,17 @@
     <p:sldId id="287" r:id="rId24"/>
     <p:sldId id="288" r:id="rId25"/>
     <p:sldId id="289" r:id="rId26"/>
-    <p:sldId id="280" r:id="rId27"/>
-    <p:sldId id="261" r:id="rId28"/>
-    <p:sldId id="263" r:id="rId29"/>
-    <p:sldId id="291" r:id="rId30"/>
-    <p:sldId id="281" r:id="rId31"/>
-    <p:sldId id="265" r:id="rId32"/>
-    <p:sldId id="260" r:id="rId33"/>
-    <p:sldId id="292" r:id="rId34"/>
-    <p:sldId id="293" r:id="rId35"/>
-    <p:sldId id="279" r:id="rId36"/>
+    <p:sldId id="294" r:id="rId27"/>
+    <p:sldId id="280" r:id="rId28"/>
+    <p:sldId id="261" r:id="rId29"/>
+    <p:sldId id="263" r:id="rId30"/>
+    <p:sldId id="291" r:id="rId31"/>
+    <p:sldId id="281" r:id="rId32"/>
+    <p:sldId id="265" r:id="rId33"/>
+    <p:sldId id="260" r:id="rId34"/>
+    <p:sldId id="292" r:id="rId35"/>
+    <p:sldId id="293" r:id="rId36"/>
+    <p:sldId id="279" r:id="rId37"/>
   </p:sldIdLst>
   <p:sldSz cx="12192000" cy="6858000"/>
   <p:notesSz cx="6858000" cy="9144000"/>
@@ -873,6 +874,90 @@
     <p:extLst>
       <p:ext uri="{BB962C8B-B14F-4D97-AF65-F5344CB8AC3E}">
         <p14:creationId xmlns:p14="http://schemas.microsoft.com/office/powerpoint/2010/main" val="358670610"/>
+      </p:ext>
+    </p:extLst>
+  </p:cSld>
+  <p:clrMapOvr>
+    <a:masterClrMapping/>
+  </p:clrMapOvr>
+</p:notes>
+</file>
+
+<file path=ppt/notesSlides/notesSlide3.xml><?xml version="1.0" encoding="utf-8"?>
+<p:notes xmlns:a="http://schemas.openxmlformats.org/drawingml/2006/main" xmlns:r="http://schemas.openxmlformats.org/officeDocument/2006/relationships" xmlns:p="http://schemas.openxmlformats.org/presentationml/2006/main">
+  <p:cSld>
+    <p:spTree>
+      <p:nvGrpSpPr>
+        <p:cNvPr id="1" name=""/>
+        <p:cNvGrpSpPr/>
+        <p:nvPr/>
+      </p:nvGrpSpPr>
+      <p:grpSpPr>
+        <a:xfrm>
+          <a:off x="0" y="0"/>
+          <a:ext cx="0" cy="0"/>
+          <a:chOff x="0" y="0"/>
+          <a:chExt cx="0" cy="0"/>
+        </a:xfrm>
+      </p:grpSpPr>
+      <p:sp>
+        <p:nvSpPr>
+          <p:cNvPr id="2" name="Slide Image Placeholder 1"/>
+          <p:cNvSpPr>
+            <a:spLocks noGrp="1" noRot="1" noChangeAspect="1"/>
+          </p:cNvSpPr>
+          <p:nvPr>
+            <p:ph type="sldImg"/>
+          </p:nvPr>
+        </p:nvSpPr>
+        <p:spPr/>
+      </p:sp>
+      <p:sp>
+        <p:nvSpPr>
+          <p:cNvPr id="3" name="Notes Placeholder 2"/>
+          <p:cNvSpPr>
+            <a:spLocks noGrp="1"/>
+          </p:cNvSpPr>
+          <p:nvPr>
+            <p:ph type="body" idx="1"/>
+          </p:nvPr>
+        </p:nvSpPr>
+        <p:spPr/>
+        <p:txBody>
+          <a:bodyPr/>
+          <a:lstStyle/>
+          <a:p>
+            <a:endParaRPr lang="en-SG" dirty="0"/>
+          </a:p>
+        </p:txBody>
+      </p:sp>
+      <p:sp>
+        <p:nvSpPr>
+          <p:cNvPr id="4" name="Slide Number Placeholder 3"/>
+          <p:cNvSpPr>
+            <a:spLocks noGrp="1"/>
+          </p:cNvSpPr>
+          <p:nvPr>
+            <p:ph type="sldNum" sz="quarter" idx="5"/>
+          </p:nvPr>
+        </p:nvSpPr>
+        <p:spPr/>
+        <p:txBody>
+          <a:bodyPr/>
+          <a:lstStyle/>
+          <a:p>
+            <a:fld id="{38EFF46E-6B43-41F9-9272-B566D03A251C}" type="slidenum">
+              <a:rPr lang="en-US" smtClean="0"/>
+              <a:t>23</a:t>
+            </a:fld>
+            <a:endParaRPr lang="en-US"/>
+          </a:p>
+        </p:txBody>
+      </p:sp>
+    </p:spTree>
+    <p:extLst>
+      <p:ext uri="{BB962C8B-B14F-4D97-AF65-F5344CB8AC3E}">
+        <p14:creationId xmlns:p14="http://schemas.microsoft.com/office/powerpoint/2010/main" val="3879371435"/>
       </p:ext>
     </p:extLst>
   </p:cSld>
@@ -23208,25 +23293,203 @@
           <p:cNvPr id="2" name="Title 1">
             <a:extLst>
               <a:ext uri="{FF2B5EF4-FFF2-40B4-BE49-F238E27FC236}">
-                <a16:creationId xmlns:a16="http://schemas.microsoft.com/office/drawing/2014/main" id="{73EAA816-5C1B-40BC-3690-8801F897016A}"/>
-              </a:ext>
-            </a:extLst>
-          </p:cNvPr>
-          <p:cNvSpPr>
-            <a:spLocks noGrp="1"/>
-          </p:cNvSpPr>
-          <p:nvPr>
-            <p:ph type="ctrTitle"/>
-          </p:nvPr>
-        </p:nvSpPr>
-        <p:spPr/>
-        <p:txBody>
-          <a:bodyPr/>
-          <a:lstStyle/>
-          <a:p>
-            <a:r>
-              <a:rPr lang="en-SG" dirty="0"/>
-              <a:t>TUNING</a:t>
+                <a16:creationId xmlns:a16="http://schemas.microsoft.com/office/drawing/2014/main" id="{82C2E210-BB34-3F57-B270-74B5A24AE9D7}"/>
+              </a:ext>
+            </a:extLst>
+          </p:cNvPr>
+          <p:cNvSpPr>
+            <a:spLocks noGrp="1"/>
+          </p:cNvSpPr>
+          <p:nvPr>
+            <p:ph type="title"/>
+          </p:nvPr>
+        </p:nvSpPr>
+        <p:spPr>
+          <a:xfrm>
+            <a:off x="612185" y="685800"/>
+            <a:ext cx="9141415" cy="1532788"/>
+          </a:xfrm>
+        </p:spPr>
+        <p:txBody>
+          <a:bodyPr anchor="b">
+            <a:normAutofit/>
+          </a:bodyPr>
+          <a:lstStyle/>
+          <a:p>
+            <a:r>
+              <a:rPr lang="en-US" dirty="0"/>
+              <a:t>Clean.py</a:t>
+            </a:r>
+            <a:endParaRPr lang="en-SG" dirty="0"/>
+          </a:p>
+        </p:txBody>
+      </p:sp>
+      <p:sp>
+        <p:nvSpPr>
+          <p:cNvPr id="7" name="Content Placeholder 2">
+            <a:extLst>
+              <a:ext uri="{FF2B5EF4-FFF2-40B4-BE49-F238E27FC236}">
+                <a16:creationId xmlns:a16="http://schemas.microsoft.com/office/drawing/2014/main" id="{5C66DAF8-6679-7EB8-B7AA-EE69BE75F420}"/>
+              </a:ext>
+            </a:extLst>
+          </p:cNvPr>
+          <p:cNvSpPr>
+            <a:spLocks noGrp="1"/>
+          </p:cNvSpPr>
+          <p:nvPr>
+            <p:ph sz="quarter" idx="13"/>
+          </p:nvPr>
+        </p:nvSpPr>
+        <p:spPr>
+          <a:xfrm>
+            <a:off x="612185" y="2958704"/>
+            <a:ext cx="10884415" cy="3566639"/>
+          </a:xfrm>
+        </p:spPr>
+        <p:txBody>
+          <a:bodyPr anchor="t">
+            <a:noAutofit/>
+          </a:bodyPr>
+          <a:lstStyle/>
+          <a:p>
+            <a:pPr marL="285750" indent="-285750">
+              <a:lnSpc>
+                <a:spcPct val="140000"/>
+              </a:lnSpc>
+              <a:buFontTx/>
+              <a:buChar char="-"/>
+            </a:pPr>
+            <a:r>
+              <a:rPr lang="en-SG" sz="1600" b="1" dirty="0"/>
+              <a:t>Input Processing:</a:t>
+            </a:r>
+            <a:r>
+              <a:rPr lang="en-SG" sz="1600" dirty="0"/>
+              <a:t> The </a:t>
+            </a:r>
+            <a:r>
+              <a:rPr lang="en-SG" sz="1600" dirty="0" err="1"/>
+              <a:t>clean_gas_monitoring</a:t>
+            </a:r>
+            <a:r>
+              <a:rPr lang="en-SG" sz="1600" dirty="0"/>
+              <a:t>() function takes the raw dataset and returns a cleaned version.</a:t>
+            </a:r>
+          </a:p>
+          <a:p>
+            <a:pPr marL="285750" indent="-285750">
+              <a:lnSpc>
+                <a:spcPct val="140000"/>
+              </a:lnSpc>
+              <a:buFontTx/>
+              <a:buChar char="-"/>
+            </a:pPr>
+            <a:r>
+              <a:rPr lang="en-SG" sz="1600" b="1" dirty="0"/>
+              <a:t>Invalid Value Detection:</a:t>
+            </a:r>
+            <a:r>
+              <a:rPr lang="en-SG" sz="1600" dirty="0"/>
+              <a:t> Unrealistic values (e.g., temperature &gt; 60°C, humidity outside 0–100%, negative CO₂ readings) are identified and replaced with missing values (</a:t>
+            </a:r>
+            <a:r>
+              <a:rPr lang="en-SG" sz="1600" dirty="0" err="1"/>
+              <a:t>NaN</a:t>
+            </a:r>
+            <a:r>
+              <a:rPr lang="en-SG" sz="1600" dirty="0"/>
+              <a:t>).</a:t>
+            </a:r>
+          </a:p>
+          <a:p>
+            <a:pPr marL="285750" indent="-285750">
+              <a:lnSpc>
+                <a:spcPct val="140000"/>
+              </a:lnSpc>
+              <a:buFontTx/>
+              <a:buChar char="-"/>
+            </a:pPr>
+            <a:r>
+              <a:rPr lang="en-SG" sz="1600" b="1" dirty="0"/>
+              <a:t>Missing Value Imputation:</a:t>
+            </a:r>
+            <a:r>
+              <a:rPr lang="en-SG" sz="1600" dirty="0"/>
+              <a:t> Numerical features are filled using the </a:t>
+            </a:r>
+            <a:r>
+              <a:rPr lang="en-SG" sz="1600" b="1" dirty="0"/>
+              <a:t>median</a:t>
+            </a:r>
+            <a:r>
+              <a:rPr lang="en-SG" sz="1600" dirty="0"/>
+              <a:t>, while categorical/discrete features (e.g., </a:t>
+            </a:r>
+            <a:r>
+              <a:rPr lang="en-SG" sz="1600" dirty="0" err="1"/>
+              <a:t>CO_GasSensor</a:t>
+            </a:r>
+            <a:r>
+              <a:rPr lang="en-SG" sz="1600" dirty="0"/>
+              <a:t>, Ambient Light Level) use the </a:t>
+            </a:r>
+            <a:r>
+              <a:rPr lang="en-SG" sz="1600" b="1" dirty="0"/>
+              <a:t>mode</a:t>
+            </a:r>
+            <a:r>
+              <a:rPr lang="en-SG" sz="1600" dirty="0"/>
+              <a:t>.</a:t>
+            </a:r>
+          </a:p>
+          <a:p>
+            <a:pPr marL="285750" indent="-285750">
+              <a:lnSpc>
+                <a:spcPct val="140000"/>
+              </a:lnSpc>
+              <a:buFontTx/>
+              <a:buChar char="-"/>
+            </a:pPr>
+            <a:r>
+              <a:rPr lang="en-SG" sz="1600" b="1" dirty="0"/>
+              <a:t>Category Standardization:</a:t>
+            </a:r>
+            <a:r>
+              <a:rPr lang="en-SG" sz="1600" dirty="0"/>
+              <a:t> Different naming formats for </a:t>
+            </a:r>
+            <a:r>
+              <a:rPr lang="en-SG" sz="1600" b="1" dirty="0"/>
+              <a:t>HVAC operation modes</a:t>
+            </a:r>
+            <a:r>
+              <a:rPr lang="en-SG" sz="1600" dirty="0"/>
+              <a:t> and </a:t>
+            </a:r>
+            <a:r>
+              <a:rPr lang="en-SG" sz="1600" b="1" dirty="0"/>
+              <a:t>activity levels</a:t>
+            </a:r>
+            <a:r>
+              <a:rPr lang="en-SG" sz="1600" dirty="0"/>
+              <a:t> are mapped into consistent categories using predefined dictionaries.</a:t>
+            </a:r>
+          </a:p>
+          <a:p>
+            <a:pPr marL="285750" indent="-285750">
+              <a:lnSpc>
+                <a:spcPct val="140000"/>
+              </a:lnSpc>
+              <a:buFontTx/>
+              <a:buChar char="-"/>
+            </a:pPr>
+            <a:r>
+              <a:rPr lang="en-SG" sz="1600" b="1" dirty="0"/>
+              <a:t>Outcome:</a:t>
+            </a:r>
+            <a:r>
+              <a:rPr lang="en-SG" sz="1600" dirty="0"/>
+              <a:t> Produces a cleaner, more reliable, and standardized dataset suitable for further analysis and machine learning.</a:t>
             </a:r>
           </a:p>
         </p:txBody>
@@ -23234,7 +23497,7 @@
     </p:spTree>
     <p:extLst>
       <p:ext uri="{BB962C8B-B14F-4D97-AF65-F5344CB8AC3E}">
-        <p14:creationId xmlns:p14="http://schemas.microsoft.com/office/powerpoint/2010/main" val="74595788"/>
+        <p14:creationId xmlns:p14="http://schemas.microsoft.com/office/powerpoint/2010/main" val="2538094305"/>
       </p:ext>
     </p:extLst>
   </p:cSld>
@@ -23266,92 +23529,33 @@
           <p:cNvPr id="2" name="Title 1">
             <a:extLst>
               <a:ext uri="{FF2B5EF4-FFF2-40B4-BE49-F238E27FC236}">
-                <a16:creationId xmlns:a16="http://schemas.microsoft.com/office/drawing/2014/main" id="{608378AE-EF7F-6F80-0A73-BD8BFF959868}"/>
-              </a:ext>
-            </a:extLst>
-          </p:cNvPr>
-          <p:cNvSpPr>
-            <a:spLocks noGrp="1"/>
-          </p:cNvSpPr>
-          <p:nvPr>
-            <p:ph type="title"/>
-          </p:nvPr>
-        </p:nvSpPr>
-        <p:spPr>
-          <a:xfrm>
-            <a:off x="612185" y="685800"/>
-            <a:ext cx="9141415" cy="1532788"/>
-          </a:xfrm>
-        </p:spPr>
-        <p:txBody>
-          <a:bodyPr anchor="b">
-            <a:normAutofit/>
-          </a:bodyPr>
+                <a16:creationId xmlns:a16="http://schemas.microsoft.com/office/drawing/2014/main" id="{73EAA816-5C1B-40BC-3690-8801F897016A}"/>
+              </a:ext>
+            </a:extLst>
+          </p:cNvPr>
+          <p:cNvSpPr>
+            <a:spLocks noGrp="1"/>
+          </p:cNvSpPr>
+          <p:nvPr>
+            <p:ph type="ctrTitle"/>
+          </p:nvPr>
+        </p:nvSpPr>
+        <p:spPr/>
+        <p:txBody>
+          <a:bodyPr/>
           <a:lstStyle/>
           <a:p>
             <a:r>
               <a:rPr lang="en-SG" dirty="0"/>
-              <a:t>Random Forest</a:t>
-            </a:r>
-          </a:p>
-        </p:txBody>
-      </p:sp>
-      <p:sp>
-        <p:nvSpPr>
-          <p:cNvPr id="3" name="Content Placeholder 2">
-            <a:extLst>
-              <a:ext uri="{FF2B5EF4-FFF2-40B4-BE49-F238E27FC236}">
-                <a16:creationId xmlns:a16="http://schemas.microsoft.com/office/drawing/2014/main" id="{33D49B3D-8C9C-5AA3-92F1-70026ADA236D}"/>
-              </a:ext>
-            </a:extLst>
-          </p:cNvPr>
-          <p:cNvSpPr>
-            <a:spLocks noGrp="1"/>
-          </p:cNvSpPr>
-          <p:nvPr>
-            <p:ph sz="quarter" idx="13"/>
-          </p:nvPr>
-        </p:nvSpPr>
-        <p:spPr>
-          <a:xfrm>
-            <a:off x="612185" y="2958705"/>
-            <a:ext cx="9141415" cy="3213494"/>
-          </a:xfrm>
-        </p:spPr>
-        <p:txBody>
-          <a:bodyPr anchor="t">
-            <a:normAutofit/>
-          </a:bodyPr>
-          <a:lstStyle/>
-          <a:p>
-            <a:r>
-              <a:rPr lang="en-US" b="1" dirty="0"/>
-              <a:t>Ensemble</a:t>
-            </a:r>
-            <a:r>
-              <a:rPr lang="en-US" dirty="0"/>
-              <a:t> — A technique that combines multiple weak models (decision trees) to produce a stronger prediction. Random Forest builds hundreds of trees on random subsets of data and averages their outputs, reducing overfitting compared to a single tree.</a:t>
-            </a:r>
-          </a:p>
-          <a:p>
-            <a:r>
-              <a:rPr lang="en-US" b="1" dirty="0" err="1"/>
-              <a:t>n_estimators</a:t>
-            </a:r>
-            <a:r>
-              <a:rPr lang="en-US" dirty="0"/>
-              <a:t> — The number of decision trees in the Random Forest. More trees generally improve performance but increase training time. RF sweeps this from 10 to 300 to find the optimal value.</a:t>
-            </a:r>
-          </a:p>
-          <a:p>
-            <a:endParaRPr lang="en-SG" dirty="0"/>
+              <a:t>TUNING</a:t>
+            </a:r>
           </a:p>
         </p:txBody>
       </p:sp>
     </p:spTree>
     <p:extLst>
       <p:ext uri="{BB962C8B-B14F-4D97-AF65-F5344CB8AC3E}">
-        <p14:creationId xmlns:p14="http://schemas.microsoft.com/office/powerpoint/2010/main" val="512507100"/>
+        <p14:creationId xmlns:p14="http://schemas.microsoft.com/office/powerpoint/2010/main" val="74595788"/>
       </p:ext>
     </p:extLst>
   </p:cSld>
@@ -23383,7 +23587,7 @@
           <p:cNvPr id="2" name="Title 1">
             <a:extLst>
               <a:ext uri="{FF2B5EF4-FFF2-40B4-BE49-F238E27FC236}">
-                <a16:creationId xmlns:a16="http://schemas.microsoft.com/office/drawing/2014/main" id="{E2A0EA7F-C1F0-A036-A564-A533B5D04308}"/>
+                <a16:creationId xmlns:a16="http://schemas.microsoft.com/office/drawing/2014/main" id="{608378AE-EF7F-6F80-0A73-BD8BFF959868}"/>
               </a:ext>
             </a:extLst>
           </p:cNvPr>
@@ -23407,14 +23611,9 @@
           <a:lstStyle/>
           <a:p>
             <a:r>
-              <a:rPr lang="en-SG" sz="6100" b="1" dirty="0"/>
-              <a:t>K-Nearest </a:t>
-            </a:r>
-            <a:r>
-              <a:rPr lang="en-SG" sz="6100" b="1" dirty="0" err="1"/>
-              <a:t>Neighbors</a:t>
-            </a:r>
-            <a:endParaRPr lang="en-SG" sz="6100" dirty="0"/>
+              <a:rPr lang="en-SG" dirty="0"/>
+              <a:t>Random Forest</a:t>
+            </a:r>
           </a:p>
         </p:txBody>
       </p:sp>
@@ -23423,7 +23622,7 @@
           <p:cNvPr id="3" name="Content Placeholder 2">
             <a:extLst>
               <a:ext uri="{FF2B5EF4-FFF2-40B4-BE49-F238E27FC236}">
-                <a16:creationId xmlns:a16="http://schemas.microsoft.com/office/drawing/2014/main" id="{FA018F92-7D93-B0E9-B040-E5DC74976F11}"/>
+                <a16:creationId xmlns:a16="http://schemas.microsoft.com/office/drawing/2014/main" id="{33D49B3D-8C9C-5AA3-92F1-70026ADA236D}"/>
               </a:ext>
             </a:extLst>
           </p:cNvPr>
@@ -23447,21 +23646,33 @@
           <a:lstStyle/>
           <a:p>
             <a:r>
-              <a:rPr lang="en-US" sz="2800" b="1" dirty="0" err="1"/>
-              <a:t>GridSearchCV</a:t>
-            </a:r>
-            <a:r>
-              <a:rPr lang="en-US" sz="2800" dirty="0"/>
-              <a:t> — An automated search that tries every combination of hyperparameters (e.g., different neighbor counts and distance metrics for KNN) using cross-validation, then picks the combination with the best score.</a:t>
-            </a:r>
-            <a:endParaRPr lang="en-SG" sz="2800" dirty="0"/>
+              <a:rPr lang="en-US" b="1" dirty="0"/>
+              <a:t>Ensemble</a:t>
+            </a:r>
+            <a:r>
+              <a:rPr lang="en-US" dirty="0"/>
+              <a:t> — A technique that combines multiple weak models (decision trees) to produce a stronger prediction. Random Forest builds hundreds of trees on random subsets of data and averages their outputs, reducing overfitting compared to a single tree.</a:t>
+            </a:r>
+          </a:p>
+          <a:p>
+            <a:r>
+              <a:rPr lang="en-US" b="1" dirty="0" err="1"/>
+              <a:t>n_estimators</a:t>
+            </a:r>
+            <a:r>
+              <a:rPr lang="en-US" dirty="0"/>
+              <a:t> — The number of decision trees in the Random Forest. More trees generally improve performance but increase training time. RF sweeps this from 10 to 300 to find the optimal value.</a:t>
+            </a:r>
+          </a:p>
+          <a:p>
+            <a:endParaRPr lang="en-SG" dirty="0"/>
           </a:p>
         </p:txBody>
       </p:sp>
     </p:spTree>
     <p:extLst>
       <p:ext uri="{BB962C8B-B14F-4D97-AF65-F5344CB8AC3E}">
-        <p14:creationId xmlns:p14="http://schemas.microsoft.com/office/powerpoint/2010/main" val="4219239425"/>
+        <p14:creationId xmlns:p14="http://schemas.microsoft.com/office/powerpoint/2010/main" val="512507100"/>
       </p:ext>
     </p:extLst>
   </p:cSld>
@@ -23493,7 +23704,7 @@
           <p:cNvPr id="2" name="Title 1">
             <a:extLst>
               <a:ext uri="{FF2B5EF4-FFF2-40B4-BE49-F238E27FC236}">
-                <a16:creationId xmlns:a16="http://schemas.microsoft.com/office/drawing/2014/main" id="{7BCA37B9-217F-D459-3DB9-22FA97E4AA44}"/>
+                <a16:creationId xmlns:a16="http://schemas.microsoft.com/office/drawing/2014/main" id="{E2A0EA7F-C1F0-A036-A564-A533B5D04308}"/>
               </a:ext>
             </a:extLst>
           </p:cNvPr>
@@ -23517,9 +23728,14 @@
           <a:lstStyle/>
           <a:p>
             <a:r>
-              <a:rPr lang="en-SG" sz="6700" dirty="0"/>
-              <a:t>Logistic regression</a:t>
-            </a:r>
+              <a:rPr lang="en-SG" sz="6100" b="1" dirty="0"/>
+              <a:t>K-Nearest </a:t>
+            </a:r>
+            <a:r>
+              <a:rPr lang="en-SG" sz="6100" b="1" dirty="0" err="1"/>
+              <a:t>Neighbors</a:t>
+            </a:r>
+            <a:endParaRPr lang="en-SG" sz="6100" dirty="0"/>
           </a:p>
         </p:txBody>
       </p:sp>
@@ -23528,7 +23744,7 @@
           <p:cNvPr id="3" name="Content Placeholder 2">
             <a:extLst>
               <a:ext uri="{FF2B5EF4-FFF2-40B4-BE49-F238E27FC236}">
-                <a16:creationId xmlns:a16="http://schemas.microsoft.com/office/drawing/2014/main" id="{2D2535EC-99CD-3889-1D65-499FAD240725}"/>
+                <a16:creationId xmlns:a16="http://schemas.microsoft.com/office/drawing/2014/main" id="{FA018F92-7D93-B0E9-B040-E5DC74976F11}"/>
               </a:ext>
             </a:extLst>
           </p:cNvPr>
@@ -23541,145 +23757,32 @@
         </p:nvSpPr>
         <p:spPr>
           <a:xfrm>
-            <a:off x="612185" y="2708920"/>
-            <a:ext cx="10524375" cy="3960439"/>
+            <a:off x="612185" y="2958705"/>
+            <a:ext cx="9141415" cy="3213494"/>
           </a:xfrm>
         </p:spPr>
         <p:txBody>
           <a:bodyPr anchor="t">
-            <a:noAutofit/>
-          </a:bodyPr>
-          <a:lstStyle/>
-          <a:p>
-            <a:pPr>
-              <a:lnSpc>
-                <a:spcPct val="140000"/>
-              </a:lnSpc>
-            </a:pPr>
-            <a:r>
-              <a:rPr lang="en-US" sz="1400" b="1" dirty="0"/>
-              <a:t>Multinomial</a:t>
-            </a:r>
-            <a:r>
-              <a:rPr lang="en-US" sz="1400" dirty="0"/>
-              <a:t> — A classification strategy that treats all classes simultaneously using a </a:t>
-            </a:r>
-            <a:r>
-              <a:rPr lang="en-US" sz="1400" dirty="0" err="1"/>
-              <a:t>softmax</a:t>
-            </a:r>
-            <a:r>
-              <a:rPr lang="en-US" sz="1400" dirty="0"/>
-              <a:t> function, producing a probability for each class that sums to 1.</a:t>
-            </a:r>
-          </a:p>
-          <a:p>
-            <a:pPr>
-              <a:lnSpc>
-                <a:spcPct val="140000"/>
-              </a:lnSpc>
-            </a:pPr>
-            <a:r>
-              <a:rPr lang="en-US" sz="1400" b="1" dirty="0"/>
-              <a:t>L2 regularization</a:t>
-            </a:r>
-            <a:r>
-              <a:rPr lang="en-US" sz="1400" dirty="0"/>
-              <a:t> — The default penalty in logistic regression. It adds the sum of squared coefficients to the loss function, </a:t>
-            </a:r>
-            <a:r>
-              <a:rPr lang="en-US" sz="1400" dirty="0" err="1"/>
-              <a:t>penalising</a:t>
-            </a:r>
-            <a:r>
-              <a:rPr lang="en-US" sz="1400" dirty="0"/>
-              <a:t> large coefficients and preventing overfitting. In scikit-learn 1.8, L2 is auto-selected when using the </a:t>
-            </a:r>
-            <a:r>
-              <a:rPr lang="en-US" sz="1400" dirty="0" err="1"/>
-              <a:t>lbfgs</a:t>
-            </a:r>
-            <a:r>
-              <a:rPr lang="en-US" sz="1400" dirty="0"/>
-              <a:t> solver — even though penalty='l2' is no longer written explicitly in code.</a:t>
-            </a:r>
-          </a:p>
-          <a:p>
-            <a:pPr>
-              <a:lnSpc>
-                <a:spcPct val="140000"/>
-              </a:lnSpc>
-            </a:pPr>
-            <a:r>
-              <a:rPr lang="en-US" sz="1400" b="1" dirty="0"/>
-              <a:t>Regularization strength (C)</a:t>
-            </a:r>
-            <a:r>
-              <a:rPr lang="en-US" sz="1400" dirty="0"/>
-              <a:t> — Controls how much the model is allowed to grow its coefficients by controlling the L2 penalty. Small C means strong regularization (simpler model, less overfitting); large C means weak regularization (more complex, can overfit). This is the primary tuning knob for LR.</a:t>
-            </a:r>
-          </a:p>
-          <a:p>
-            <a:pPr>
-              <a:lnSpc>
-                <a:spcPct val="140000"/>
-              </a:lnSpc>
-            </a:pPr>
-            <a:r>
-              <a:rPr lang="en-US" sz="1400" b="1" dirty="0"/>
-              <a:t>L-BFGS</a:t>
-            </a:r>
-            <a:r>
-              <a:rPr lang="en-US" sz="1400" dirty="0"/>
-              <a:t> — The default </a:t>
-            </a:r>
-            <a:r>
-              <a:rPr lang="en-US" sz="1400" dirty="0" err="1"/>
-              <a:t>optimisation</a:t>
-            </a:r>
-            <a:r>
-              <a:rPr lang="en-US" sz="1400" dirty="0"/>
-              <a:t> algorithm used by Logistic Regression. It iteratively adjusts coefficients to </a:t>
-            </a:r>
-            <a:r>
-              <a:rPr lang="en-US" sz="1400" dirty="0" err="1"/>
-              <a:t>minimise</a:t>
-            </a:r>
-            <a:r>
-              <a:rPr lang="en-US" sz="1400" dirty="0"/>
-              <a:t> the loss function (error + L2 penalty). Unlike tree-based models (RF) or distance-based models (KNN), LR needs an </a:t>
-            </a:r>
-            <a:r>
-              <a:rPr lang="en-US" sz="1400" dirty="0" err="1"/>
-              <a:t>optimiser</a:t>
-            </a:r>
-            <a:r>
-              <a:rPr lang="en-US" sz="1400" dirty="0"/>
-              <a:t> to find its coefficients.</a:t>
-            </a:r>
-          </a:p>
-          <a:p>
-            <a:pPr>
-              <a:lnSpc>
-                <a:spcPct val="140000"/>
-              </a:lnSpc>
-            </a:pPr>
-            <a:endParaRPr lang="en-SG" sz="1400" dirty="0"/>
-          </a:p>
-          <a:p>
-            <a:pPr>
-              <a:lnSpc>
-                <a:spcPct val="140000"/>
-              </a:lnSpc>
-            </a:pPr>
-            <a:endParaRPr lang="en-SG" sz="1400" dirty="0"/>
+            <a:normAutofit/>
+          </a:bodyPr>
+          <a:lstStyle/>
+          <a:p>
+            <a:r>
+              <a:rPr lang="en-US" sz="2800" b="1" dirty="0" err="1"/>
+              <a:t>GridSearchCV</a:t>
+            </a:r>
+            <a:r>
+              <a:rPr lang="en-US" sz="2800" dirty="0"/>
+              <a:t> — An automated search that tries every combination of hyperparameters (e.g., different neighbor counts and distance metrics for KNN) using cross-validation, then picks the combination with the best score.</a:t>
+            </a:r>
+            <a:endParaRPr lang="en-SG" sz="2800" dirty="0"/>
           </a:p>
         </p:txBody>
       </p:sp>
     </p:spTree>
     <p:extLst>
       <p:ext uri="{BB962C8B-B14F-4D97-AF65-F5344CB8AC3E}">
-        <p14:creationId xmlns:p14="http://schemas.microsoft.com/office/powerpoint/2010/main" val="1114470984"/>
+        <p14:creationId xmlns:p14="http://schemas.microsoft.com/office/powerpoint/2010/main" val="4219239425"/>
       </p:ext>
     </p:extLst>
   </p:cSld>
@@ -23711,33 +23814,193 @@
           <p:cNvPr id="2" name="Title 1">
             <a:extLst>
               <a:ext uri="{FF2B5EF4-FFF2-40B4-BE49-F238E27FC236}">
-                <a16:creationId xmlns:a16="http://schemas.microsoft.com/office/drawing/2014/main" id="{049AC35F-F0FB-34E9-FE1B-745437307D4B}"/>
-              </a:ext>
-            </a:extLst>
-          </p:cNvPr>
-          <p:cNvSpPr>
-            <a:spLocks noGrp="1"/>
-          </p:cNvSpPr>
-          <p:nvPr>
-            <p:ph type="ctrTitle"/>
-          </p:nvPr>
-        </p:nvSpPr>
-        <p:spPr/>
-        <p:txBody>
-          <a:bodyPr/>
-          <a:lstStyle/>
-          <a:p>
-            <a:r>
-              <a:rPr lang="en-SG" dirty="0"/>
-              <a:t>METRICS</a:t>
-            </a:r>
+                <a16:creationId xmlns:a16="http://schemas.microsoft.com/office/drawing/2014/main" id="{7BCA37B9-217F-D459-3DB9-22FA97E4AA44}"/>
+              </a:ext>
+            </a:extLst>
+          </p:cNvPr>
+          <p:cNvSpPr>
+            <a:spLocks noGrp="1"/>
+          </p:cNvSpPr>
+          <p:nvPr>
+            <p:ph type="title"/>
+          </p:nvPr>
+        </p:nvSpPr>
+        <p:spPr>
+          <a:xfrm>
+            <a:off x="612185" y="685800"/>
+            <a:ext cx="9141415" cy="1532788"/>
+          </a:xfrm>
+        </p:spPr>
+        <p:txBody>
+          <a:bodyPr anchor="b">
+            <a:normAutofit/>
+          </a:bodyPr>
+          <a:lstStyle/>
+          <a:p>
+            <a:r>
+              <a:rPr lang="en-SG" sz="6700" dirty="0"/>
+              <a:t>Logistic regression</a:t>
+            </a:r>
+          </a:p>
+        </p:txBody>
+      </p:sp>
+      <p:sp>
+        <p:nvSpPr>
+          <p:cNvPr id="3" name="Content Placeholder 2">
+            <a:extLst>
+              <a:ext uri="{FF2B5EF4-FFF2-40B4-BE49-F238E27FC236}">
+                <a16:creationId xmlns:a16="http://schemas.microsoft.com/office/drawing/2014/main" id="{2D2535EC-99CD-3889-1D65-499FAD240725}"/>
+              </a:ext>
+            </a:extLst>
+          </p:cNvPr>
+          <p:cNvSpPr>
+            <a:spLocks noGrp="1"/>
+          </p:cNvSpPr>
+          <p:nvPr>
+            <p:ph sz="quarter" idx="13"/>
+          </p:nvPr>
+        </p:nvSpPr>
+        <p:spPr>
+          <a:xfrm>
+            <a:off x="612185" y="2708920"/>
+            <a:ext cx="10524375" cy="3960439"/>
+          </a:xfrm>
+        </p:spPr>
+        <p:txBody>
+          <a:bodyPr anchor="t">
+            <a:noAutofit/>
+          </a:bodyPr>
+          <a:lstStyle/>
+          <a:p>
+            <a:pPr>
+              <a:lnSpc>
+                <a:spcPct val="140000"/>
+              </a:lnSpc>
+            </a:pPr>
+            <a:r>
+              <a:rPr lang="en-US" sz="1400" b="1" dirty="0"/>
+              <a:t>Multinomial</a:t>
+            </a:r>
+            <a:r>
+              <a:rPr lang="en-US" sz="1400" dirty="0"/>
+              <a:t> — A classification strategy that treats all classes simultaneously using a </a:t>
+            </a:r>
+            <a:r>
+              <a:rPr lang="en-US" sz="1400" dirty="0" err="1"/>
+              <a:t>softmax</a:t>
+            </a:r>
+            <a:r>
+              <a:rPr lang="en-US" sz="1400" dirty="0"/>
+              <a:t> function, producing a probability for each class that sums to 1.</a:t>
+            </a:r>
+          </a:p>
+          <a:p>
+            <a:pPr>
+              <a:lnSpc>
+                <a:spcPct val="140000"/>
+              </a:lnSpc>
+            </a:pPr>
+            <a:r>
+              <a:rPr lang="en-US" sz="1400" b="1" dirty="0"/>
+              <a:t>L2 regularization</a:t>
+            </a:r>
+            <a:r>
+              <a:rPr lang="en-US" sz="1400" dirty="0"/>
+              <a:t> — The default penalty in logistic regression. It adds the sum of squared coefficients to the loss function, </a:t>
+            </a:r>
+            <a:r>
+              <a:rPr lang="en-US" sz="1400" dirty="0" err="1"/>
+              <a:t>penalising</a:t>
+            </a:r>
+            <a:r>
+              <a:rPr lang="en-US" sz="1400" dirty="0"/>
+              <a:t> large coefficients and preventing overfitting. In scikit-learn 1.8, L2 is auto-selected when using the </a:t>
+            </a:r>
+            <a:r>
+              <a:rPr lang="en-US" sz="1400" dirty="0" err="1"/>
+              <a:t>lbfgs</a:t>
+            </a:r>
+            <a:r>
+              <a:rPr lang="en-US" sz="1400" dirty="0"/>
+              <a:t> solver — even though penalty='l2' is no longer written explicitly in code.</a:t>
+            </a:r>
+          </a:p>
+          <a:p>
+            <a:pPr>
+              <a:lnSpc>
+                <a:spcPct val="140000"/>
+              </a:lnSpc>
+            </a:pPr>
+            <a:r>
+              <a:rPr lang="en-US" sz="1400" b="1" dirty="0"/>
+              <a:t>Regularization strength (C)</a:t>
+            </a:r>
+            <a:r>
+              <a:rPr lang="en-US" sz="1400" dirty="0"/>
+              <a:t> — Controls how much the model is allowed to grow its coefficients by controlling the L2 penalty. Small C means strong regularization (simpler model, less overfitting); large C means weak regularization (more complex, can overfit). This is the primary tuning knob for LR.</a:t>
+            </a:r>
+          </a:p>
+          <a:p>
+            <a:pPr>
+              <a:lnSpc>
+                <a:spcPct val="140000"/>
+              </a:lnSpc>
+            </a:pPr>
+            <a:r>
+              <a:rPr lang="en-US" sz="1400" b="1" dirty="0"/>
+              <a:t>L-BFGS</a:t>
+            </a:r>
+            <a:r>
+              <a:rPr lang="en-US" sz="1400" dirty="0"/>
+              <a:t> — The default </a:t>
+            </a:r>
+            <a:r>
+              <a:rPr lang="en-US" sz="1400" dirty="0" err="1"/>
+              <a:t>optimisation</a:t>
+            </a:r>
+            <a:r>
+              <a:rPr lang="en-US" sz="1400" dirty="0"/>
+              <a:t> algorithm used by Logistic Regression. It iteratively adjusts coefficients to </a:t>
+            </a:r>
+            <a:r>
+              <a:rPr lang="en-US" sz="1400" dirty="0" err="1"/>
+              <a:t>minimise</a:t>
+            </a:r>
+            <a:r>
+              <a:rPr lang="en-US" sz="1400" dirty="0"/>
+              <a:t> the loss function (error + L2 penalty). Unlike tree-based models (RF) or distance-based models (KNN), LR needs an </a:t>
+            </a:r>
+            <a:r>
+              <a:rPr lang="en-US" sz="1400" dirty="0" err="1"/>
+              <a:t>optimiser</a:t>
+            </a:r>
+            <a:r>
+              <a:rPr lang="en-US" sz="1400" dirty="0"/>
+              <a:t> to find its coefficients.</a:t>
+            </a:r>
+          </a:p>
+          <a:p>
+            <a:pPr>
+              <a:lnSpc>
+                <a:spcPct val="140000"/>
+              </a:lnSpc>
+            </a:pPr>
+            <a:endParaRPr lang="en-SG" sz="1400" dirty="0"/>
+          </a:p>
+          <a:p>
+            <a:pPr>
+              <a:lnSpc>
+                <a:spcPct val="140000"/>
+              </a:lnSpc>
+            </a:pPr>
+            <a:endParaRPr lang="en-SG" sz="1400" dirty="0"/>
           </a:p>
         </p:txBody>
       </p:sp>
     </p:spTree>
     <p:extLst>
       <p:ext uri="{BB962C8B-B14F-4D97-AF65-F5344CB8AC3E}">
-        <p14:creationId xmlns:p14="http://schemas.microsoft.com/office/powerpoint/2010/main" val="838733558"/>
+        <p14:creationId xmlns:p14="http://schemas.microsoft.com/office/powerpoint/2010/main" val="1114470984"/>
       </p:ext>
     </p:extLst>
   </p:cSld>
@@ -23769,15 +24032,15 @@
           <p:cNvPr id="2" name="Title 1">
             <a:extLst>
               <a:ext uri="{FF2B5EF4-FFF2-40B4-BE49-F238E27FC236}">
-                <a16:creationId xmlns:a16="http://schemas.microsoft.com/office/drawing/2014/main" id="{41DF196D-C65C-0E3E-EB97-06ADA54B0DE1}"/>
-              </a:ext>
-            </a:extLst>
-          </p:cNvPr>
-          <p:cNvSpPr>
-            <a:spLocks noGrp="1"/>
-          </p:cNvSpPr>
-          <p:nvPr>
-            <p:ph type="title"/>
+                <a16:creationId xmlns:a16="http://schemas.microsoft.com/office/drawing/2014/main" id="{049AC35F-F0FB-34E9-FE1B-745437307D4B}"/>
+              </a:ext>
+            </a:extLst>
+          </p:cNvPr>
+          <p:cNvSpPr>
+            <a:spLocks noGrp="1"/>
+          </p:cNvSpPr>
+          <p:nvPr>
+            <p:ph type="ctrTitle"/>
           </p:nvPr>
         </p:nvSpPr>
         <p:spPr/>
@@ -23787,106 +24050,15 @@
           <a:p>
             <a:r>
               <a:rPr lang="en-SG" dirty="0"/>
-              <a:t>METRICS (ALL MODELS)</a:t>
-            </a:r>
-          </a:p>
-        </p:txBody>
-      </p:sp>
-      <p:sp>
-        <p:nvSpPr>
-          <p:cNvPr id="3" name="Content Placeholder 2">
-            <a:extLst>
-              <a:ext uri="{FF2B5EF4-FFF2-40B4-BE49-F238E27FC236}">
-                <a16:creationId xmlns:a16="http://schemas.microsoft.com/office/drawing/2014/main" id="{BBAA60F8-6290-8070-731D-501118826B17}"/>
-              </a:ext>
-            </a:extLst>
-          </p:cNvPr>
-          <p:cNvSpPr>
-            <a:spLocks noGrp="1"/>
-          </p:cNvSpPr>
-          <p:nvPr>
-            <p:ph idx="1"/>
-          </p:nvPr>
-        </p:nvSpPr>
-        <p:spPr/>
-        <p:txBody>
-          <a:bodyPr/>
-          <a:lstStyle/>
-          <a:p>
-            <a:r>
-              <a:rPr lang="en-US" b="1" dirty="0"/>
-              <a:t>F1-Score</a:t>
-            </a:r>
-            <a:r>
-              <a:rPr lang="en-US" dirty="0"/>
-              <a:t> — The harmonic mean of precision and recall. Unlike accuracy (which counts correct vs incorrect), F1 balances false positives and false negatives. This is our primary metric because it punishes models that guess the majority class and ignore rare but critical events. A high F1-Score means both precision and recall are strong — few false alarms and few missed detections.</a:t>
-            </a:r>
-          </a:p>
-          <a:p>
-            <a:r>
-              <a:rPr lang="en-US" b="1" dirty="0"/>
-              <a:t>Precision</a:t>
-            </a:r>
-            <a:r>
-              <a:rPr lang="en-US" dirty="0"/>
-              <a:t> — Of all the times the model predicted a class (e.g. "High Activity"), how many were actually correct? High precision means few false alarms.</a:t>
-            </a:r>
-          </a:p>
-          <a:p>
-            <a:r>
-              <a:rPr lang="en-US" b="1" dirty="0"/>
-              <a:t>Recall</a:t>
-            </a:r>
-            <a:r>
-              <a:rPr lang="en-US" dirty="0"/>
-              <a:t> — Of all the actual instances of a class, how many did the model catch? High recall means few missed events.</a:t>
-            </a:r>
-          </a:p>
-          <a:p>
-            <a:r>
-              <a:rPr lang="en-US" b="1" dirty="0"/>
-              <a:t>Weighted F1 (</a:t>
-            </a:r>
-            <a:r>
-              <a:rPr lang="en-US" b="1" dirty="0" err="1"/>
-              <a:t>wtd</a:t>
-            </a:r>
-            <a:r>
-              <a:rPr lang="en-US" b="1" dirty="0"/>
-              <a:t>)</a:t>
-            </a:r>
-            <a:r>
-              <a:rPr lang="en-US" dirty="0"/>
-              <a:t> — Averages each class's F1 weighted by the number of samples in that class. This gives a representative view of overall performance since larger classes contribute more — if you randomly sample a prediction, this score reflects expected accuracy. However, because Low Activity makes up 57.7% of the dataset, a strong score on Low can mask poor performance on Moderate or High Activity. This is not ideal for eldercare where detecting rare events matters most. Weighted F1 is reported alongside macro F1 to give a complete picture of both per-sample and per-class performance. A high weighted F1 means the model performs well on the majority class (Low Activity), but can still miss rare events if macro F1 is low.</a:t>
-            </a:r>
-          </a:p>
-          <a:p>
-            <a:r>
-              <a:rPr lang="en-US" b="1" dirty="0"/>
-              <a:t>Macro F1</a:t>
-            </a:r>
-            <a:r>
-              <a:rPr lang="en-US" dirty="0"/>
-              <a:t> — While weighted F1 reflects per-sample accuracy, macro F1 tells you whether the model works for ALL classes. It averages each class's F1 equally regardless of sample count, so a low F1 on High Activity hurts the score just as much as a low F1 on Low Activity. This is the stricter metric used to select the best model, because detecting rare activity shifts matters most. Together with weighted F1, macro ensures the model performs well on common cases without ignoring the critical rare ones. A high macro F1 means the model performs well on ALL classes equally — harder to achieve but safer for eldercare, since a rare missed event is </a:t>
-            </a:r>
-            <a:r>
-              <a:rPr lang="en-US" dirty="0" err="1"/>
-              <a:t>penalised</a:t>
-            </a:r>
-            <a:r>
-              <a:rPr lang="en-US" dirty="0"/>
-              <a:t> as much as a common one.</a:t>
-            </a:r>
-          </a:p>
-          <a:p>
-            <a:endParaRPr lang="en-SG" dirty="0"/>
+              <a:t>METRICS</a:t>
+            </a:r>
           </a:p>
         </p:txBody>
       </p:sp>
     </p:spTree>
     <p:extLst>
       <p:ext uri="{BB962C8B-B14F-4D97-AF65-F5344CB8AC3E}">
-        <p14:creationId xmlns:p14="http://schemas.microsoft.com/office/powerpoint/2010/main" val="2745255356"/>
+        <p14:creationId xmlns:p14="http://schemas.microsoft.com/office/powerpoint/2010/main" val="838733558"/>
       </p:ext>
     </p:extLst>
   </p:cSld>
@@ -23918,7 +24090,7 @@
           <p:cNvPr id="2" name="Title 1">
             <a:extLst>
               <a:ext uri="{FF2B5EF4-FFF2-40B4-BE49-F238E27FC236}">
-                <a16:creationId xmlns:a16="http://schemas.microsoft.com/office/drawing/2014/main" id="{05873BBD-8696-B347-44E2-640F6E3ABAFB}"/>
+                <a16:creationId xmlns:a16="http://schemas.microsoft.com/office/drawing/2014/main" id="{41DF196D-C65C-0E3E-EB97-06ADA54B0DE1}"/>
               </a:ext>
             </a:extLst>
           </p:cNvPr>
@@ -23929,21 +24101,14 @@
             <p:ph type="title"/>
           </p:nvPr>
         </p:nvSpPr>
-        <p:spPr>
-          <a:xfrm>
-            <a:off x="612185" y="685800"/>
-            <a:ext cx="9141415" cy="1532788"/>
-          </a:xfrm>
-        </p:spPr>
-        <p:txBody>
-          <a:bodyPr anchor="b">
-            <a:normAutofit/>
-          </a:bodyPr>
+        <p:spPr/>
+        <p:txBody>
+          <a:bodyPr/>
           <a:lstStyle/>
           <a:p>
             <a:r>
               <a:rPr lang="en-SG" dirty="0"/>
-              <a:t>Metrics used</a:t>
+              <a:t>METRICS (ALL MODELS)</a:t>
             </a:r>
           </a:p>
         </p:txBody>
@@ -23953,46 +24118,96 @@
           <p:cNvPr id="3" name="Content Placeholder 2">
             <a:extLst>
               <a:ext uri="{FF2B5EF4-FFF2-40B4-BE49-F238E27FC236}">
-                <a16:creationId xmlns:a16="http://schemas.microsoft.com/office/drawing/2014/main" id="{9244914A-7BC2-D2D4-803F-2CE6DB45867A}"/>
-              </a:ext>
-            </a:extLst>
-          </p:cNvPr>
-          <p:cNvSpPr>
-            <a:spLocks noGrp="1"/>
-          </p:cNvSpPr>
-          <p:nvPr>
-            <p:ph sz="quarter" idx="13"/>
-          </p:nvPr>
-        </p:nvSpPr>
-        <p:spPr>
-          <a:xfrm>
-            <a:off x="612185" y="2958705"/>
-            <a:ext cx="9141415" cy="3213494"/>
-          </a:xfrm>
-        </p:spPr>
-        <p:txBody>
-          <a:bodyPr anchor="t">
-            <a:normAutofit/>
-          </a:bodyPr>
-          <a:lstStyle/>
-          <a:p>
-            <a:pPr>
-              <a:lnSpc>
-                <a:spcPct val="140000"/>
-              </a:lnSpc>
-            </a:pPr>
-            <a:r>
-              <a:rPr lang="en-US" sz="1500" dirty="0"/>
-              <a:t>For an eldercare early warning system, F1-Score is selected as the primary evaluation metric over standard classification accuracy due to inherent class imbalances in smart-home sensor logs. Because elderly residents spend a disproportionate amount of time resting, the dataset is naturally heavily skewed toward "Low Activity" instances. Relying on standard accuracy would reward a naive model that consistently predicts the majority class while failing entirely to catch critical movement transitions. F1-Score mitigates this bias by calculating the precision and recall for each activity class independently and taking their unweighted average. This ensures that "Low", "Moderate", and "High" activity states are treated with equal importance, directly penalizing the pipeline if it fails to accurately detect less frequent but potentially life-saving activity shifts.</a:t>
-            </a:r>
-            <a:endParaRPr lang="en-SG" sz="1500" dirty="0"/>
+                <a16:creationId xmlns:a16="http://schemas.microsoft.com/office/drawing/2014/main" id="{BBAA60F8-6290-8070-731D-501118826B17}"/>
+              </a:ext>
+            </a:extLst>
+          </p:cNvPr>
+          <p:cNvSpPr>
+            <a:spLocks noGrp="1"/>
+          </p:cNvSpPr>
+          <p:nvPr>
+            <p:ph idx="1"/>
+          </p:nvPr>
+        </p:nvSpPr>
+        <p:spPr/>
+        <p:txBody>
+          <a:bodyPr/>
+          <a:lstStyle/>
+          <a:p>
+            <a:r>
+              <a:rPr lang="en-US" b="1" dirty="0"/>
+              <a:t>F1-Score</a:t>
+            </a:r>
+            <a:r>
+              <a:rPr lang="en-US" dirty="0"/>
+              <a:t> — The harmonic mean of precision and recall. Unlike accuracy (which counts correct vs incorrect), F1 balances false positives and false negatives. This is our primary metric because it punishes models that guess the majority class and ignore rare but critical events. A high F1-Score means both precision and recall are strong — few false alarms and few missed detections.</a:t>
+            </a:r>
+          </a:p>
+          <a:p>
+            <a:r>
+              <a:rPr lang="en-US" b="1" dirty="0"/>
+              <a:t>Precision</a:t>
+            </a:r>
+            <a:r>
+              <a:rPr lang="en-US" dirty="0"/>
+              <a:t> — Of all the times the model predicted a class (e.g. "High Activity"), how many were actually correct? High precision means few false alarms.</a:t>
+            </a:r>
+          </a:p>
+          <a:p>
+            <a:r>
+              <a:rPr lang="en-US" b="1" dirty="0"/>
+              <a:t>Recall</a:t>
+            </a:r>
+            <a:r>
+              <a:rPr lang="en-US" dirty="0"/>
+              <a:t> — Of all the actual instances of a class, how many did the model catch? High recall means few missed events.</a:t>
+            </a:r>
+          </a:p>
+          <a:p>
+            <a:r>
+              <a:rPr lang="en-US" b="1" dirty="0"/>
+              <a:t>Weighted F1 (</a:t>
+            </a:r>
+            <a:r>
+              <a:rPr lang="en-US" b="1" dirty="0" err="1"/>
+              <a:t>wtd</a:t>
+            </a:r>
+            <a:r>
+              <a:rPr lang="en-US" b="1" dirty="0"/>
+              <a:t>)</a:t>
+            </a:r>
+            <a:r>
+              <a:rPr lang="en-US" dirty="0"/>
+              <a:t> — Averages each class's F1 weighted by the number of samples in that class. This gives a representative view of overall performance since larger classes contribute more — if you randomly sample a prediction, this score reflects expected accuracy. However, because Low Activity makes up 57.7% of the dataset, a strong score on Low can mask poor performance on Moderate or High Activity. This is not ideal for eldercare where detecting rare events matters most. Weighted F1 is reported alongside macro F1 to give a complete picture of both per-sample and per-class performance. A high weighted F1 means the model performs well on the majority class (Low Activity), but can still miss rare events if macro F1 is low.</a:t>
+            </a:r>
+          </a:p>
+          <a:p>
+            <a:r>
+              <a:rPr lang="en-US" b="1" dirty="0"/>
+              <a:t>Macro F1</a:t>
+            </a:r>
+            <a:r>
+              <a:rPr lang="en-US" dirty="0"/>
+              <a:t> — While weighted F1 reflects per-sample accuracy, macro F1 tells you whether the model works for ALL classes. It averages each class's F1 equally regardless of sample count, so a low F1 on High Activity hurts the score just as much as a low F1 on Low Activity. This is the stricter metric used to select the best model, because detecting rare activity shifts matters most. Together with weighted F1, macro ensures the model performs well on common cases without ignoring the critical rare ones. A high macro F1 means the model performs well on ALL classes equally — harder to achieve but safer for eldercare, since a rare missed event is </a:t>
+            </a:r>
+            <a:r>
+              <a:rPr lang="en-US" dirty="0" err="1"/>
+              <a:t>penalised</a:t>
+            </a:r>
+            <a:r>
+              <a:rPr lang="en-US" dirty="0"/>
+              <a:t> as much as a common one.</a:t>
+            </a:r>
+          </a:p>
+          <a:p>
+            <a:endParaRPr lang="en-SG" dirty="0"/>
           </a:p>
         </p:txBody>
       </p:sp>
     </p:spTree>
     <p:extLst>
       <p:ext uri="{BB962C8B-B14F-4D97-AF65-F5344CB8AC3E}">
-        <p14:creationId xmlns:p14="http://schemas.microsoft.com/office/powerpoint/2010/main" val="3631814381"/>
+        <p14:creationId xmlns:p14="http://schemas.microsoft.com/office/powerpoint/2010/main" val="2745255356"/>
       </p:ext>
     </p:extLst>
   </p:cSld>
@@ -24193,33 +24408,81 @@
           <p:cNvPr id="2" name="Title 1">
             <a:extLst>
               <a:ext uri="{FF2B5EF4-FFF2-40B4-BE49-F238E27FC236}">
-                <a16:creationId xmlns:a16="http://schemas.microsoft.com/office/drawing/2014/main" id="{917A164B-6142-D78E-30B2-4D4E577450D2}"/>
-              </a:ext>
-            </a:extLst>
-          </p:cNvPr>
-          <p:cNvSpPr>
-            <a:spLocks noGrp="1"/>
-          </p:cNvSpPr>
-          <p:nvPr>
-            <p:ph type="ctrTitle"/>
-          </p:nvPr>
-        </p:nvSpPr>
-        <p:spPr/>
-        <p:txBody>
-          <a:bodyPr/>
+                <a16:creationId xmlns:a16="http://schemas.microsoft.com/office/drawing/2014/main" id="{05873BBD-8696-B347-44E2-640F6E3ABAFB}"/>
+              </a:ext>
+            </a:extLst>
+          </p:cNvPr>
+          <p:cNvSpPr>
+            <a:spLocks noGrp="1"/>
+          </p:cNvSpPr>
+          <p:nvPr>
+            <p:ph type="title"/>
+          </p:nvPr>
+        </p:nvSpPr>
+        <p:spPr>
+          <a:xfrm>
+            <a:off x="612185" y="685800"/>
+            <a:ext cx="9141415" cy="1532788"/>
+          </a:xfrm>
+        </p:spPr>
+        <p:txBody>
+          <a:bodyPr anchor="b">
+            <a:normAutofit/>
+          </a:bodyPr>
           <a:lstStyle/>
           <a:p>
             <a:r>
               <a:rPr lang="en-SG" dirty="0"/>
-              <a:t>COMPARISON</a:t>
-            </a:r>
+              <a:t>Metrics used</a:t>
+            </a:r>
+          </a:p>
+        </p:txBody>
+      </p:sp>
+      <p:sp>
+        <p:nvSpPr>
+          <p:cNvPr id="3" name="Content Placeholder 2">
+            <a:extLst>
+              <a:ext uri="{FF2B5EF4-FFF2-40B4-BE49-F238E27FC236}">
+                <a16:creationId xmlns:a16="http://schemas.microsoft.com/office/drawing/2014/main" id="{9244914A-7BC2-D2D4-803F-2CE6DB45867A}"/>
+              </a:ext>
+            </a:extLst>
+          </p:cNvPr>
+          <p:cNvSpPr>
+            <a:spLocks noGrp="1"/>
+          </p:cNvSpPr>
+          <p:nvPr>
+            <p:ph sz="quarter" idx="13"/>
+          </p:nvPr>
+        </p:nvSpPr>
+        <p:spPr>
+          <a:xfrm>
+            <a:off x="612185" y="2958705"/>
+            <a:ext cx="9141415" cy="3213494"/>
+          </a:xfrm>
+        </p:spPr>
+        <p:txBody>
+          <a:bodyPr anchor="t">
+            <a:normAutofit/>
+          </a:bodyPr>
+          <a:lstStyle/>
+          <a:p>
+            <a:pPr>
+              <a:lnSpc>
+                <a:spcPct val="140000"/>
+              </a:lnSpc>
+            </a:pPr>
+            <a:r>
+              <a:rPr lang="en-US" sz="1500" dirty="0"/>
+              <a:t>For an eldercare early warning system, F1-Score is selected as the primary evaluation metric over standard classification accuracy due to inherent class imbalances in smart-home sensor logs. Because elderly residents spend a disproportionate amount of time resting, the dataset is naturally heavily skewed toward "Low Activity" instances. Relying on standard accuracy would reward a naive model that consistently predicts the majority class while failing entirely to catch critical movement transitions. F1-Score mitigates this bias by calculating the precision and recall for each activity class independently and taking their unweighted average. This ensures that "Low", "Moderate", and "High" activity states are treated with equal importance, directly penalizing the pipeline if it fails to accurately detect less frequent but potentially life-saving activity shifts.</a:t>
+            </a:r>
+            <a:endParaRPr lang="en-SG" sz="1500" dirty="0"/>
           </a:p>
         </p:txBody>
       </p:sp>
     </p:spTree>
     <p:extLst>
       <p:ext uri="{BB962C8B-B14F-4D97-AF65-F5344CB8AC3E}">
-        <p14:creationId xmlns:p14="http://schemas.microsoft.com/office/powerpoint/2010/main" val="1168183960"/>
+        <p14:creationId xmlns:p14="http://schemas.microsoft.com/office/powerpoint/2010/main" val="3631814381"/>
       </p:ext>
     </p:extLst>
   </p:cSld>
@@ -24251,6 +24514,64 @@
           <p:cNvPr id="2" name="Title 1">
             <a:extLst>
               <a:ext uri="{FF2B5EF4-FFF2-40B4-BE49-F238E27FC236}">
+                <a16:creationId xmlns:a16="http://schemas.microsoft.com/office/drawing/2014/main" id="{917A164B-6142-D78E-30B2-4D4E577450D2}"/>
+              </a:ext>
+            </a:extLst>
+          </p:cNvPr>
+          <p:cNvSpPr>
+            <a:spLocks noGrp="1"/>
+          </p:cNvSpPr>
+          <p:nvPr>
+            <p:ph type="ctrTitle"/>
+          </p:nvPr>
+        </p:nvSpPr>
+        <p:spPr/>
+        <p:txBody>
+          <a:bodyPr/>
+          <a:lstStyle/>
+          <a:p>
+            <a:r>
+              <a:rPr lang="en-SG" dirty="0"/>
+              <a:t>COMPARISON</a:t>
+            </a:r>
+          </a:p>
+        </p:txBody>
+      </p:sp>
+    </p:spTree>
+    <p:extLst>
+      <p:ext uri="{BB962C8B-B14F-4D97-AF65-F5344CB8AC3E}">
+        <p14:creationId xmlns:p14="http://schemas.microsoft.com/office/powerpoint/2010/main" val="1168183960"/>
+      </p:ext>
+    </p:extLst>
+  </p:cSld>
+  <p:clrMapOvr>
+    <a:masterClrMapping/>
+  </p:clrMapOvr>
+</p:sld>
+</file>
+
+<file path=ppt/slides/slide32.xml><?xml version="1.0" encoding="utf-8"?>
+<p:sld xmlns:a="http://schemas.openxmlformats.org/drawingml/2006/main" xmlns:r="http://schemas.openxmlformats.org/officeDocument/2006/relationships" xmlns:p="http://schemas.openxmlformats.org/presentationml/2006/main">
+  <p:cSld>
+    <p:spTree>
+      <p:nvGrpSpPr>
+        <p:cNvPr id="1" name=""/>
+        <p:cNvGrpSpPr/>
+        <p:nvPr/>
+      </p:nvGrpSpPr>
+      <p:grpSpPr>
+        <a:xfrm>
+          <a:off x="0" y="0"/>
+          <a:ext cx="0" cy="0"/>
+          <a:chOff x="0" y="0"/>
+          <a:chExt cx="0" cy="0"/>
+        </a:xfrm>
+      </p:grpSpPr>
+      <p:sp>
+        <p:nvSpPr>
+          <p:cNvPr id="2" name="Title 1">
+            <a:extLst>
+              <a:ext uri="{FF2B5EF4-FFF2-40B4-BE49-F238E27FC236}">
                 <a16:creationId xmlns:a16="http://schemas.microsoft.com/office/drawing/2014/main" id="{9CFC4A9C-B598-F116-4E8D-407083A2ED77}"/>
               </a:ext>
             </a:extLst>
@@ -24312,7 +24633,7 @@
 </p:sld>
 </file>
 
-<file path=ppt/slides/slide32.xml><?xml version="1.0" encoding="utf-8"?>
+<file path=ppt/slides/slide33.xml><?xml version="1.0" encoding="utf-8"?>
 <p:sld xmlns:a="http://schemas.openxmlformats.org/drawingml/2006/main" xmlns:r="http://schemas.openxmlformats.org/officeDocument/2006/relationships" xmlns:p="http://schemas.openxmlformats.org/presentationml/2006/main">
   <p:cSld>
     <p:spTree>
@@ -25899,26 +26220,6 @@
 </file>
 
 <file path=customXml/item1.xml><?xml version="1.0" encoding="utf-8"?>
-<p:properties xmlns:p="http://schemas.microsoft.com/office/2006/metadata/properties" xmlns:xsi="http://www.w3.org/2001/XMLSchema-instance" xmlns:pc="http://schemas.microsoft.com/office/infopath/2007/PartnerControls">
-  <documentManagement>
-    <_ip_UnifiedCompliancePolicyUIAction xmlns="http://schemas.microsoft.com/sharepoint/v3" xsi:nil="true"/>
-    <Image xmlns="71af3243-3dd4-4a8d-8c0d-dd76da1f02a5">
-      <Url xsi:nil="true"/>
-      <Description xsi:nil="true"/>
-    </Image>
-    <Status xmlns="71af3243-3dd4-4a8d-8c0d-dd76da1f02a5">Not started</Status>
-    <Background xmlns="71af3243-3dd4-4a8d-8c0d-dd76da1f02a5">false</Background>
-    <_ip_UnifiedCompliancePolicyProperties xmlns="http://schemas.microsoft.com/sharepoint/v3" xsi:nil="true"/>
-    <ImageTagsTaxHTField xmlns="71af3243-3dd4-4a8d-8c0d-dd76da1f02a5">
-      <Terms xmlns="http://schemas.microsoft.com/office/infopath/2007/PartnerControls"/>
-    </ImageTagsTaxHTField>
-    <TaxCatchAll xmlns="230e9df3-be65-4c73-a93b-d1236ebd677e" xsi:nil="true"/>
-    <MediaServiceKeyPoints xmlns="71af3243-3dd4-4a8d-8c0d-dd76da1f02a5" xsi:nil="true"/>
-  </documentManagement>
-</p:properties>
-</file>
-
-<file path=customXml/item2.xml><?xml version="1.0" encoding="utf-8"?>
 <ct:contentTypeSchema xmlns:ct="http://schemas.microsoft.com/office/2006/metadata/contentType" xmlns:ma="http://schemas.microsoft.com/office/2006/metadata/properties/metaAttributes" ct:_="" ma:_="" ma:contentTypeName="Document" ma:contentTypeID="0x01010079F111ED35F8CC479449609E8A0923A6" ma:contentTypeVersion="32" ma:contentTypeDescription="Create a new document." ma:contentTypeScope="" ma:versionID="0635a23c60cc3de58ab4c1efc88efc6e">
   <xsd:schema xmlns:xsd="http://www.w3.org/2001/XMLSchema" xmlns:xs="http://www.w3.org/2001/XMLSchema" xmlns:p="http://schemas.microsoft.com/office/2006/metadata/properties" xmlns:ns1="http://schemas.microsoft.com/sharepoint/v3" xmlns:ns2="71af3243-3dd4-4a8d-8c0d-dd76da1f02a5" xmlns:ns3="16c05727-aa75-4e4a-9b5f-8a80a1165891" xmlns:ns4="230e9df3-be65-4c73-a93b-d1236ebd677e" targetNamespace="http://schemas.microsoft.com/office/2006/metadata/properties" ma:root="true" ma:fieldsID="b2ec4e1d644ed04c8d3fd0ef60d056a4" ns1:_="" ns2:_="" ns3:_="" ns4:_="">
     <xsd:import namespace="http://schemas.microsoft.com/sharepoint/v3"/>
@@ -26248,6 +26549,26 @@
 </ct:contentTypeSchema>
 </file>
 
+<file path=customXml/item2.xml><?xml version="1.0" encoding="utf-8"?>
+<p:properties xmlns:p="http://schemas.microsoft.com/office/2006/metadata/properties" xmlns:xsi="http://www.w3.org/2001/XMLSchema-instance" xmlns:pc="http://schemas.microsoft.com/office/infopath/2007/PartnerControls">
+  <documentManagement>
+    <_ip_UnifiedCompliancePolicyUIAction xmlns="http://schemas.microsoft.com/sharepoint/v3" xsi:nil="true"/>
+    <Image xmlns="71af3243-3dd4-4a8d-8c0d-dd76da1f02a5">
+      <Url xsi:nil="true"/>
+      <Description xsi:nil="true"/>
+    </Image>
+    <Status xmlns="71af3243-3dd4-4a8d-8c0d-dd76da1f02a5">Not started</Status>
+    <Background xmlns="71af3243-3dd4-4a8d-8c0d-dd76da1f02a5">false</Background>
+    <_ip_UnifiedCompliancePolicyProperties xmlns="http://schemas.microsoft.com/sharepoint/v3" xsi:nil="true"/>
+    <ImageTagsTaxHTField xmlns="71af3243-3dd4-4a8d-8c0d-dd76da1f02a5">
+      <Terms xmlns="http://schemas.microsoft.com/office/infopath/2007/PartnerControls"/>
+    </ImageTagsTaxHTField>
+    <TaxCatchAll xmlns="230e9df3-be65-4c73-a93b-d1236ebd677e" xsi:nil="true"/>
+    <MediaServiceKeyPoints xmlns="71af3243-3dd4-4a8d-8c0d-dd76da1f02a5" xsi:nil="true"/>
+  </documentManagement>
+</p:properties>
+</file>
+
 <file path=customXml/item3.xml><?xml version="1.0" encoding="utf-8"?>
 <?mso-contentType ?>
 <FormTemplates xmlns="http://schemas.microsoft.com/sharepoint/v3/contenttype/forms">
@@ -26258,18 +26579,6 @@
 </file>
 
 <file path=customXml/itemProps1.xml><?xml version="1.0" encoding="utf-8"?>
-<ds:datastoreItem xmlns:ds="http://schemas.openxmlformats.org/officeDocument/2006/customXml" ds:itemID="{EEA42C18-4C38-43BB-8CE3-C963EDA9CBBA}">
-  <ds:schemaRefs>
-    <ds:schemaRef ds:uri="http://schemas.microsoft.com/office/2006/metadata/properties"/>
-    <ds:schemaRef ds:uri="http://schemas.microsoft.com/office/infopath/2007/PartnerControls"/>
-    <ds:schemaRef ds:uri="http://schemas.microsoft.com/sharepoint/v3"/>
-    <ds:schemaRef ds:uri="71af3243-3dd4-4a8d-8c0d-dd76da1f02a5"/>
-    <ds:schemaRef ds:uri="230e9df3-be65-4c73-a93b-d1236ebd677e"/>
-  </ds:schemaRefs>
-</ds:datastoreItem>
-</file>
-
-<file path=customXml/itemProps2.xml><?xml version="1.0" encoding="utf-8"?>
 <ds:datastoreItem xmlns:ds="http://schemas.openxmlformats.org/officeDocument/2006/customXml" ds:itemID="{CC3B381C-6232-408C-B65A-8475398E4C36}">
   <ds:schemaRefs>
     <ds:schemaRef ds:uri="http://schemas.microsoft.com/office/2006/metadata/contentType"/>
@@ -26290,6 +26599,18 @@
 </ds:datastoreItem>
 </file>
 
+<file path=customXml/itemProps2.xml><?xml version="1.0" encoding="utf-8"?>
+<ds:datastoreItem xmlns:ds="http://schemas.openxmlformats.org/officeDocument/2006/customXml" ds:itemID="{EEA42C18-4C38-43BB-8CE3-C963EDA9CBBA}">
+  <ds:schemaRefs>
+    <ds:schemaRef ds:uri="http://schemas.microsoft.com/office/2006/metadata/properties"/>
+    <ds:schemaRef ds:uri="http://schemas.microsoft.com/office/infopath/2007/PartnerControls"/>
+    <ds:schemaRef ds:uri="http://schemas.microsoft.com/sharepoint/v3"/>
+    <ds:schemaRef ds:uri="71af3243-3dd4-4a8d-8c0d-dd76da1f02a5"/>
+    <ds:schemaRef ds:uri="230e9df3-be65-4c73-a93b-d1236ebd677e"/>
+  </ds:schemaRefs>
+</ds:datastoreItem>
+</file>
+
 <file path=customXml/itemProps3.xml><?xml version="1.0" encoding="utf-8"?>
 <ds:datastoreItem xmlns:ds="http://schemas.openxmlformats.org/officeDocument/2006/customXml" ds:itemID="{0DE0AE46-2EED-447A-8B24-DFD65B70D448}">
   <ds:schemaRefs>

</xml_diff>